<commit_message>
[fix] change include_extensions default to review all files
Previously defaulted to c,cpp,h,hpp,java which silently skipped
other file types. Now defaults to empty (no filtering) so all
files are reviewed. Users can still restrict via config if needed.

Co-Authored-By: Claude Opus 4.6 <noreply@anthropic.com>
</commit_message>
<xml_diff>
--- a/docs/SOP-cross-platform.pptx
+++ b/docs/SOP-cross-platform.pptx
@@ -3991,7 +3991,7 @@
               </a:defRPr>
             </a:pPr>
             <a:r>
-              <a:t>設定審查副檔名</a:t>
+              <a:t>限縮審查副檔名（預設：不限制，審查所有檔案）</a:t>
             </a:r>
           </a:p>
           <a:p>
@@ -4009,7 +4009,7 @@
               </a:defRPr>
             </a:pPr>
             <a:r>
-              <a:t>$ ai-review config set review include_extensions "c,cpp,h,hpp,java,py,json"</a:t>
+              <a:t>$ ai-review config set review include_extensions "c,cpp,h,py"</a:t>
             </a:r>
           </a:p>
           <a:p>
@@ -4027,7 +4027,7 @@
               </a:defRPr>
             </a:pPr>
             <a:r>
-              <a:t>預設：c, cpp, h, hpp, java</a:t>
+              <a:t>預設：空（全部檔案），有需要時再設定限縮</a:t>
             </a:r>
           </a:p>
           <a:p>

</xml_diff>

<commit_message>
[fix] update GitHub repo URL from seen0722 to jame472518-design/ai-code-review
Co-Authored-By: Claude Opus 4.6 <noreply@anthropic.com>
</commit_message>
<xml_diff>
--- a/docs/SOP-cross-platform.pptx
+++ b/docs/SOP-cross-platform.pptx
@@ -14881,7 +14881,7 @@
               </a:defRPr>
             </a:pPr>
             <a:r>
-              <a:t>Questions?  →  github.com/seen0722/ai-code-review</a:t>
+              <a:t>Questions?  →  github.com/jame472518-design/ai-code-review</a:t>
             </a:r>
           </a:p>
         </p:txBody>
@@ -17661,7 +17661,7 @@
               </a:defRPr>
             </a:pPr>
             <a:r>
-              <a:t>    seen0722/ai-code-review.git</a:t>
+              <a:t>    jame472518-design/ai-code-review.git</a:t>
             </a:r>
           </a:p>
           <a:p>
@@ -17968,7 +17968,7 @@
               </a:defRPr>
             </a:pPr>
             <a:r>
-              <a:t>    seen0722/ai-code-review.git</a:t>
+              <a:t>    jame472518-design/ai-code-review.git</a:t>
             </a:r>
           </a:p>
           <a:p>
@@ -18242,7 +18242,7 @@
               </a:defRPr>
             </a:pPr>
             <a:r>
-              <a:t>    seen0722/ai-code-review.git</a:t>
+              <a:t>    jame472518-design/ai-code-review.git</a:t>
             </a:r>
           </a:p>
           <a:p>
@@ -18400,7 +18400,7 @@
               </a:defRPr>
             </a:pPr>
             <a:r>
-              <a:t>或直接安裝：pip install git+https://github.com/seen0722/ai-code-review.git</a:t>
+              <a:t>或直接安裝：pip install git+https://github.com/jame472518-design/ai-code-review.git</a:t>
             </a:r>
           </a:p>
         </p:txBody>

</xml_diff>

<commit_message>
[docs] update cross-platform SOP PPT with init-generate-prompt on P12
Co-Authored-By: Claude Opus 4.6 (1M context) <noreply@anthropic.com>
</commit_message>
<xml_diff>
--- a/docs/SOP-cross-platform.pptx
+++ b/docs/SOP-cross-platform.pptx
@@ -5,46 +5,46 @@
     <p:sldMasterId id="2147483648" r:id="rId1"/>
   </p:sldMasterIdLst>
   <p:sldIdLst>
-    <p:sldId id="256" r:id="rId7"/>
-    <p:sldId id="257" r:id="rId8"/>
-    <p:sldId id="258" r:id="rId9"/>
-    <p:sldId id="259" r:id="rId10"/>
-    <p:sldId id="260" r:id="rId11"/>
-    <p:sldId id="261" r:id="rId12"/>
-    <p:sldId id="262" r:id="rId13"/>
-    <p:sldId id="263" r:id="rId14"/>
-    <p:sldId id="264" r:id="rId15"/>
-    <p:sldId id="265" r:id="rId16"/>
-    <p:sldId id="266" r:id="rId17"/>
-    <p:sldId id="267" r:id="rId18"/>
-    <p:sldId id="268" r:id="rId19"/>
-    <p:sldId id="269" r:id="rId20"/>
-    <p:sldId id="270" r:id="rId21"/>
-    <p:sldId id="271" r:id="rId22"/>
-    <p:sldId id="272" r:id="rId23"/>
-    <p:sldId id="273" r:id="rId24"/>
-    <p:sldId id="274" r:id="rId25"/>
-    <p:sldId id="275" r:id="rId26"/>
-    <p:sldId id="276" r:id="rId27"/>
-    <p:sldId id="277" r:id="rId28"/>
-    <p:sldId id="278" r:id="rId29"/>
-    <p:sldId id="279" r:id="rId30"/>
-    <p:sldId id="280" r:id="rId31"/>
-    <p:sldId id="281" r:id="rId32"/>
-    <p:sldId id="282" r:id="rId33"/>
-    <p:sldId id="283" r:id="rId34"/>
-    <p:sldId id="284" r:id="rId35"/>
-    <p:sldId id="285" r:id="rId36"/>
-    <p:sldId id="286" r:id="rId37"/>
-    <p:sldId id="287" r:id="rId38"/>
-    <p:sldId id="288" r:id="rId39"/>
-    <p:sldId id="289" r:id="rId40"/>
-    <p:sldId id="290" r:id="rId41"/>
-    <p:sldId id="291" r:id="rId42"/>
-    <p:sldId id="292" r:id="rId43"/>
-    <p:sldId id="293" r:id="rId44"/>
+    <p:sldId id="256" r:id="rId2"/>
+    <p:sldId id="257" r:id="rId3"/>
+    <p:sldId id="258" r:id="rId4"/>
+    <p:sldId id="259" r:id="rId5"/>
+    <p:sldId id="260" r:id="rId6"/>
+    <p:sldId id="261" r:id="rId7"/>
+    <p:sldId id="262" r:id="rId8"/>
+    <p:sldId id="263" r:id="rId9"/>
+    <p:sldId id="264" r:id="rId10"/>
+    <p:sldId id="265" r:id="rId11"/>
+    <p:sldId id="266" r:id="rId12"/>
+    <p:sldId id="267" r:id="rId13"/>
+    <p:sldId id="268" r:id="rId14"/>
+    <p:sldId id="269" r:id="rId15"/>
+    <p:sldId id="270" r:id="rId16"/>
+    <p:sldId id="271" r:id="rId17"/>
+    <p:sldId id="272" r:id="rId18"/>
+    <p:sldId id="273" r:id="rId19"/>
+    <p:sldId id="274" r:id="rId20"/>
+    <p:sldId id="275" r:id="rId21"/>
+    <p:sldId id="276" r:id="rId22"/>
+    <p:sldId id="277" r:id="rId23"/>
+    <p:sldId id="278" r:id="rId24"/>
+    <p:sldId id="279" r:id="rId25"/>
+    <p:sldId id="280" r:id="rId26"/>
+    <p:sldId id="281" r:id="rId27"/>
+    <p:sldId id="282" r:id="rId28"/>
+    <p:sldId id="283" r:id="rId29"/>
+    <p:sldId id="284" r:id="rId30"/>
+    <p:sldId id="285" r:id="rId31"/>
+    <p:sldId id="286" r:id="rId32"/>
+    <p:sldId id="287" r:id="rId33"/>
+    <p:sldId id="288" r:id="rId34"/>
+    <p:sldId id="289" r:id="rId35"/>
+    <p:sldId id="290" r:id="rId36"/>
+    <p:sldId id="291" r:id="rId37"/>
+    <p:sldId id="292" r:id="rId38"/>
+    <p:sldId id="293" r:id="rId39"/>
   </p:sldIdLst>
-  <p:sldSz cx="12191695" cy="6858000" type="screen4x3"/>
+  <p:sldSz cx="12192000" cy="6858000"/>
   <p:notesSz cx="6858000" cy="9144000"/>
   <p:defaultTextStyle>
     <a:defPPr>
@@ -141,6 +141,22 @@
       </a:defRPr>
     </a:lvl9pPr>
   </p:defaultTextStyle>
+  <p:extLst>
+    <p:ext uri="{EFAFB233-063F-42B5-8137-9DF3F51BA10A}">
+      <p15:sldGuideLst xmlns:p15="http://schemas.microsoft.com/office/powerpoint/2012/main">
+        <p15:guide id="1" orient="horz" pos="2160">
+          <p15:clr>
+            <a:srgbClr val="A4A3A4"/>
+          </p15:clr>
+        </p15:guide>
+        <p15:guide id="2" pos="2880">
+          <p15:clr>
+            <a:srgbClr val="A4A3A4"/>
+          </p15:clr>
+        </p15:guide>
+      </p15:sldGuideLst>
+    </p:ext>
+  </p:extLst>
 </p:presentation>
 </file>
 
@@ -182,10 +198,9 @@
           <a:lstStyle/>
           <a:p>
             <a:r>
-              <a:rPr lang="en-US" smtClean="0"/>
+              <a:rPr lang="en-US"/>
               <a:t>Click to edit Master title style</a:t>
             </a:r>
-            <a:endParaRPr lang="en-US"/>
           </a:p>
         </p:txBody>
       </p:sp>
@@ -301,10 +316,9 @@
           </a:lstStyle>
           <a:p>
             <a:r>
-              <a:rPr lang="en-US" smtClean="0"/>
+              <a:rPr lang="en-US"/>
               <a:t>Click to edit Master subtitle style</a:t>
             </a:r>
-            <a:endParaRPr lang="en-US"/>
           </a:p>
         </p:txBody>
       </p:sp>
@@ -325,7 +339,7 @@
           <a:p>
             <a:fld id="{5BCAD085-E8A6-8845-BD4E-CB4CCA059FC4}" type="datetimeFigureOut">
               <a:rPr lang="en-US" smtClean="0"/>
-              <a:t>1/27/13</a:t>
+              <a:t>3/18/2026</a:t>
             </a:fld>
             <a:endParaRPr lang="en-US"/>
           </a:p>
@@ -419,10 +433,9 @@
           <a:lstStyle/>
           <a:p>
             <a:r>
-              <a:rPr lang="en-US" smtClean="0"/>
+              <a:rPr lang="en-US"/>
               <a:t>Click to edit Master title style</a:t>
             </a:r>
-            <a:endParaRPr lang="en-US"/>
           </a:p>
         </p:txBody>
       </p:sp>
@@ -443,38 +456,37 @@
           <a:p>
             <a:pPr lvl="0"/>
             <a:r>
-              <a:rPr lang="en-US" smtClean="0"/>
+              <a:rPr lang="en-US"/>
               <a:t>Click to edit Master text styles</a:t>
             </a:r>
           </a:p>
           <a:p>
             <a:pPr lvl="1"/>
             <a:r>
-              <a:rPr lang="en-US" smtClean="0"/>
+              <a:rPr lang="en-US"/>
               <a:t>Second level</a:t>
             </a:r>
           </a:p>
           <a:p>
             <a:pPr lvl="2"/>
             <a:r>
-              <a:rPr lang="en-US" smtClean="0"/>
+              <a:rPr lang="en-US"/>
               <a:t>Third level</a:t>
             </a:r>
           </a:p>
           <a:p>
             <a:pPr lvl="3"/>
             <a:r>
-              <a:rPr lang="en-US" smtClean="0"/>
+              <a:rPr lang="en-US"/>
               <a:t>Fourth level</a:t>
             </a:r>
           </a:p>
           <a:p>
             <a:pPr lvl="4"/>
             <a:r>
-              <a:rPr lang="en-US" smtClean="0"/>
+              <a:rPr lang="en-US"/>
               <a:t>Fifth level</a:t>
             </a:r>
-            <a:endParaRPr lang="en-US"/>
           </a:p>
         </p:txBody>
       </p:sp>
@@ -495,7 +507,7 @@
           <a:p>
             <a:fld id="{5BCAD085-E8A6-8845-BD4E-CB4CCA059FC4}" type="datetimeFigureOut">
               <a:rPr lang="en-US" smtClean="0"/>
-              <a:t>1/27/13</a:t>
+              <a:t>3/18/2026</a:t>
             </a:fld>
             <a:endParaRPr lang="en-US"/>
           </a:p>
@@ -594,10 +606,9 @@
           <a:lstStyle/>
           <a:p>
             <a:r>
-              <a:rPr lang="en-US" smtClean="0"/>
+              <a:rPr lang="en-US"/>
               <a:t>Click to edit Master title style</a:t>
             </a:r>
-            <a:endParaRPr lang="en-US"/>
           </a:p>
         </p:txBody>
       </p:sp>
@@ -623,38 +634,37 @@
           <a:p>
             <a:pPr lvl="0"/>
             <a:r>
-              <a:rPr lang="en-US" smtClean="0"/>
+              <a:rPr lang="en-US"/>
               <a:t>Click to edit Master text styles</a:t>
             </a:r>
           </a:p>
           <a:p>
             <a:pPr lvl="1"/>
             <a:r>
-              <a:rPr lang="en-US" smtClean="0"/>
+              <a:rPr lang="en-US"/>
               <a:t>Second level</a:t>
             </a:r>
           </a:p>
           <a:p>
             <a:pPr lvl="2"/>
             <a:r>
-              <a:rPr lang="en-US" smtClean="0"/>
+              <a:rPr lang="en-US"/>
               <a:t>Third level</a:t>
             </a:r>
           </a:p>
           <a:p>
             <a:pPr lvl="3"/>
             <a:r>
-              <a:rPr lang="en-US" smtClean="0"/>
+              <a:rPr lang="en-US"/>
               <a:t>Fourth level</a:t>
             </a:r>
           </a:p>
           <a:p>
             <a:pPr lvl="4"/>
             <a:r>
-              <a:rPr lang="en-US" smtClean="0"/>
+              <a:rPr lang="en-US"/>
               <a:t>Fifth level</a:t>
             </a:r>
-            <a:endParaRPr lang="en-US"/>
           </a:p>
         </p:txBody>
       </p:sp>
@@ -675,7 +685,7 @@
           <a:p>
             <a:fld id="{5BCAD085-E8A6-8845-BD4E-CB4CCA059FC4}" type="datetimeFigureOut">
               <a:rPr lang="en-US" smtClean="0"/>
-              <a:t>1/27/13</a:t>
+              <a:t>3/18/2026</a:t>
             </a:fld>
             <a:endParaRPr lang="en-US"/>
           </a:p>
@@ -769,10 +779,9 @@
           <a:lstStyle/>
           <a:p>
             <a:r>
-              <a:rPr lang="en-US" smtClean="0"/>
+              <a:rPr lang="en-US"/>
               <a:t>Click to edit Master title style</a:t>
             </a:r>
-            <a:endParaRPr lang="en-US"/>
           </a:p>
         </p:txBody>
       </p:sp>
@@ -793,38 +802,37 @@
           <a:p>
             <a:pPr lvl="0"/>
             <a:r>
-              <a:rPr lang="en-US" smtClean="0"/>
+              <a:rPr lang="en-US"/>
               <a:t>Click to edit Master text styles</a:t>
             </a:r>
           </a:p>
           <a:p>
             <a:pPr lvl="1"/>
             <a:r>
-              <a:rPr lang="en-US" smtClean="0"/>
+              <a:rPr lang="en-US"/>
               <a:t>Second level</a:t>
             </a:r>
           </a:p>
           <a:p>
             <a:pPr lvl="2"/>
             <a:r>
-              <a:rPr lang="en-US" smtClean="0"/>
+              <a:rPr lang="en-US"/>
               <a:t>Third level</a:t>
             </a:r>
           </a:p>
           <a:p>
             <a:pPr lvl="3"/>
             <a:r>
-              <a:rPr lang="en-US" smtClean="0"/>
+              <a:rPr lang="en-US"/>
               <a:t>Fourth level</a:t>
             </a:r>
           </a:p>
           <a:p>
             <a:pPr lvl="4"/>
             <a:r>
-              <a:rPr lang="en-US" smtClean="0"/>
+              <a:rPr lang="en-US"/>
               <a:t>Fifth level</a:t>
             </a:r>
-            <a:endParaRPr lang="en-US"/>
           </a:p>
         </p:txBody>
       </p:sp>
@@ -845,7 +853,7 @@
           <a:p>
             <a:fld id="{5BCAD085-E8A6-8845-BD4E-CB4CCA059FC4}" type="datetimeFigureOut">
               <a:rPr lang="en-US" smtClean="0"/>
-              <a:t>1/27/13</a:t>
+              <a:t>3/18/2026</a:t>
             </a:fld>
             <a:endParaRPr lang="en-US"/>
           </a:p>
@@ -948,10 +956,9 @@
           </a:lstStyle>
           <a:p>
             <a:r>
-              <a:rPr lang="en-US" smtClean="0"/>
+              <a:rPr lang="en-US"/>
               <a:t>Click to edit Master title style</a:t>
             </a:r>
-            <a:endParaRPr lang="en-US"/>
           </a:p>
         </p:txBody>
       </p:sp>
@@ -1068,7 +1075,7 @@
           <a:p>
             <a:pPr lvl="0"/>
             <a:r>
-              <a:rPr lang="en-US" smtClean="0"/>
+              <a:rPr lang="en-US"/>
               <a:t>Click to edit Master text styles</a:t>
             </a:r>
           </a:p>
@@ -1091,7 +1098,7 @@
           <a:p>
             <a:fld id="{5BCAD085-E8A6-8845-BD4E-CB4CCA059FC4}" type="datetimeFigureOut">
               <a:rPr lang="en-US" smtClean="0"/>
-              <a:t>1/27/13</a:t>
+              <a:t>3/18/2026</a:t>
             </a:fld>
             <a:endParaRPr lang="en-US"/>
           </a:p>
@@ -1185,10 +1192,9 @@
           <a:lstStyle/>
           <a:p>
             <a:r>
-              <a:rPr lang="en-US" smtClean="0"/>
+              <a:rPr lang="en-US"/>
               <a:t>Click to edit Master title style</a:t>
             </a:r>
-            <a:endParaRPr lang="en-US"/>
           </a:p>
         </p:txBody>
       </p:sp>
@@ -1242,38 +1248,37 @@
           <a:p>
             <a:pPr lvl="0"/>
             <a:r>
-              <a:rPr lang="en-US" smtClean="0"/>
+              <a:rPr lang="en-US"/>
               <a:t>Click to edit Master text styles</a:t>
             </a:r>
           </a:p>
           <a:p>
             <a:pPr lvl="1"/>
             <a:r>
-              <a:rPr lang="en-US" smtClean="0"/>
+              <a:rPr lang="en-US"/>
               <a:t>Second level</a:t>
             </a:r>
           </a:p>
           <a:p>
             <a:pPr lvl="2"/>
             <a:r>
-              <a:rPr lang="en-US" smtClean="0"/>
+              <a:rPr lang="en-US"/>
               <a:t>Third level</a:t>
             </a:r>
           </a:p>
           <a:p>
             <a:pPr lvl="3"/>
             <a:r>
-              <a:rPr lang="en-US" smtClean="0"/>
+              <a:rPr lang="en-US"/>
               <a:t>Fourth level</a:t>
             </a:r>
           </a:p>
           <a:p>
             <a:pPr lvl="4"/>
             <a:r>
-              <a:rPr lang="en-US" smtClean="0"/>
+              <a:rPr lang="en-US"/>
               <a:t>Fifth level</a:t>
             </a:r>
-            <a:endParaRPr lang="en-US"/>
           </a:p>
         </p:txBody>
       </p:sp>
@@ -1327,38 +1332,37 @@
           <a:p>
             <a:pPr lvl="0"/>
             <a:r>
-              <a:rPr lang="en-US" smtClean="0"/>
+              <a:rPr lang="en-US"/>
               <a:t>Click to edit Master text styles</a:t>
             </a:r>
           </a:p>
           <a:p>
             <a:pPr lvl="1"/>
             <a:r>
-              <a:rPr lang="en-US" smtClean="0"/>
+              <a:rPr lang="en-US"/>
               <a:t>Second level</a:t>
             </a:r>
           </a:p>
           <a:p>
             <a:pPr lvl="2"/>
             <a:r>
-              <a:rPr lang="en-US" smtClean="0"/>
+              <a:rPr lang="en-US"/>
               <a:t>Third level</a:t>
             </a:r>
           </a:p>
           <a:p>
             <a:pPr lvl="3"/>
             <a:r>
-              <a:rPr lang="en-US" smtClean="0"/>
+              <a:rPr lang="en-US"/>
               <a:t>Fourth level</a:t>
             </a:r>
           </a:p>
           <a:p>
             <a:pPr lvl="4"/>
             <a:r>
-              <a:rPr lang="en-US" smtClean="0"/>
+              <a:rPr lang="en-US"/>
               <a:t>Fifth level</a:t>
             </a:r>
-            <a:endParaRPr lang="en-US"/>
           </a:p>
         </p:txBody>
       </p:sp>
@@ -1379,7 +1383,7 @@
           <a:p>
             <a:fld id="{5BCAD085-E8A6-8845-BD4E-CB4CCA059FC4}" type="datetimeFigureOut">
               <a:rPr lang="en-US" smtClean="0"/>
-              <a:t>1/27/13</a:t>
+              <a:t>3/18/2026</a:t>
             </a:fld>
             <a:endParaRPr lang="en-US"/>
           </a:p>
@@ -1477,10 +1481,9 @@
           </a:lstStyle>
           <a:p>
             <a:r>
-              <a:rPr lang="en-US" smtClean="0"/>
+              <a:rPr lang="en-US"/>
               <a:t>Click to edit Master title style</a:t>
             </a:r>
-            <a:endParaRPr lang="en-US"/>
           </a:p>
         </p:txBody>
       </p:sp>
@@ -1543,7 +1546,7 @@
           <a:p>
             <a:pPr lvl="0"/>
             <a:r>
-              <a:rPr lang="en-US" smtClean="0"/>
+              <a:rPr lang="en-US"/>
               <a:t>Click to edit Master text styles</a:t>
             </a:r>
           </a:p>
@@ -1599,38 +1602,37 @@
           <a:p>
             <a:pPr lvl="0"/>
             <a:r>
-              <a:rPr lang="en-US" smtClean="0"/>
+              <a:rPr lang="en-US"/>
               <a:t>Click to edit Master text styles</a:t>
             </a:r>
           </a:p>
           <a:p>
             <a:pPr lvl="1"/>
             <a:r>
-              <a:rPr lang="en-US" smtClean="0"/>
+              <a:rPr lang="en-US"/>
               <a:t>Second level</a:t>
             </a:r>
           </a:p>
           <a:p>
             <a:pPr lvl="2"/>
             <a:r>
-              <a:rPr lang="en-US" smtClean="0"/>
+              <a:rPr lang="en-US"/>
               <a:t>Third level</a:t>
             </a:r>
           </a:p>
           <a:p>
             <a:pPr lvl="3"/>
             <a:r>
-              <a:rPr lang="en-US" smtClean="0"/>
+              <a:rPr lang="en-US"/>
               <a:t>Fourth level</a:t>
             </a:r>
           </a:p>
           <a:p>
             <a:pPr lvl="4"/>
             <a:r>
-              <a:rPr lang="en-US" smtClean="0"/>
+              <a:rPr lang="en-US"/>
               <a:t>Fifth level</a:t>
             </a:r>
-            <a:endParaRPr lang="en-US"/>
           </a:p>
         </p:txBody>
       </p:sp>
@@ -1693,7 +1695,7 @@
           <a:p>
             <a:pPr lvl="0"/>
             <a:r>
-              <a:rPr lang="en-US" smtClean="0"/>
+              <a:rPr lang="en-US"/>
               <a:t>Click to edit Master text styles</a:t>
             </a:r>
           </a:p>
@@ -1749,38 +1751,37 @@
           <a:p>
             <a:pPr lvl="0"/>
             <a:r>
-              <a:rPr lang="en-US" smtClean="0"/>
+              <a:rPr lang="en-US"/>
               <a:t>Click to edit Master text styles</a:t>
             </a:r>
           </a:p>
           <a:p>
             <a:pPr lvl="1"/>
             <a:r>
-              <a:rPr lang="en-US" smtClean="0"/>
+              <a:rPr lang="en-US"/>
               <a:t>Second level</a:t>
             </a:r>
           </a:p>
           <a:p>
             <a:pPr lvl="2"/>
             <a:r>
-              <a:rPr lang="en-US" smtClean="0"/>
+              <a:rPr lang="en-US"/>
               <a:t>Third level</a:t>
             </a:r>
           </a:p>
           <a:p>
             <a:pPr lvl="3"/>
             <a:r>
-              <a:rPr lang="en-US" smtClean="0"/>
+              <a:rPr lang="en-US"/>
               <a:t>Fourth level</a:t>
             </a:r>
           </a:p>
           <a:p>
             <a:pPr lvl="4"/>
             <a:r>
-              <a:rPr lang="en-US" smtClean="0"/>
+              <a:rPr lang="en-US"/>
               <a:t>Fifth level</a:t>
             </a:r>
-            <a:endParaRPr lang="en-US"/>
           </a:p>
         </p:txBody>
       </p:sp>
@@ -1801,7 +1802,7 @@
           <a:p>
             <a:fld id="{5BCAD085-E8A6-8845-BD4E-CB4CCA059FC4}" type="datetimeFigureOut">
               <a:rPr lang="en-US" smtClean="0"/>
-              <a:t>1/27/13</a:t>
+              <a:t>3/18/2026</a:t>
             </a:fld>
             <a:endParaRPr lang="en-US"/>
           </a:p>
@@ -1895,10 +1896,9 @@
           <a:lstStyle/>
           <a:p>
             <a:r>
-              <a:rPr lang="en-US" smtClean="0"/>
+              <a:rPr lang="en-US"/>
               <a:t>Click to edit Master title style</a:t>
             </a:r>
-            <a:endParaRPr lang="en-US"/>
           </a:p>
         </p:txBody>
       </p:sp>
@@ -1919,7 +1919,7 @@
           <a:p>
             <a:fld id="{5BCAD085-E8A6-8845-BD4E-CB4CCA059FC4}" type="datetimeFigureOut">
               <a:rPr lang="en-US" smtClean="0"/>
-              <a:t>1/27/13</a:t>
+              <a:t>3/18/2026</a:t>
             </a:fld>
             <a:endParaRPr lang="en-US"/>
           </a:p>
@@ -2014,7 +2014,7 @@
           <a:p>
             <a:fld id="{5BCAD085-E8A6-8845-BD4E-CB4CCA059FC4}" type="datetimeFigureOut">
               <a:rPr lang="en-US" smtClean="0"/>
-              <a:t>1/27/13</a:t>
+              <a:t>3/18/2026</a:t>
             </a:fld>
             <a:endParaRPr lang="en-US"/>
           </a:p>
@@ -2117,10 +2117,9 @@
           </a:lstStyle>
           <a:p>
             <a:r>
-              <a:rPr lang="en-US" smtClean="0"/>
+              <a:rPr lang="en-US"/>
               <a:t>Click to edit Master title style</a:t>
             </a:r>
-            <a:endParaRPr lang="en-US"/>
           </a:p>
         </p:txBody>
       </p:sp>
@@ -2174,38 +2173,37 @@
           <a:p>
             <a:pPr lvl="0"/>
             <a:r>
-              <a:rPr lang="en-US" smtClean="0"/>
+              <a:rPr lang="en-US"/>
               <a:t>Click to edit Master text styles</a:t>
             </a:r>
           </a:p>
           <a:p>
             <a:pPr lvl="1"/>
             <a:r>
-              <a:rPr lang="en-US" smtClean="0"/>
+              <a:rPr lang="en-US"/>
               <a:t>Second level</a:t>
             </a:r>
           </a:p>
           <a:p>
             <a:pPr lvl="2"/>
             <a:r>
-              <a:rPr lang="en-US" smtClean="0"/>
+              <a:rPr lang="en-US"/>
               <a:t>Third level</a:t>
             </a:r>
           </a:p>
           <a:p>
             <a:pPr lvl="3"/>
             <a:r>
-              <a:rPr lang="en-US" smtClean="0"/>
+              <a:rPr lang="en-US"/>
               <a:t>Fourth level</a:t>
             </a:r>
           </a:p>
           <a:p>
             <a:pPr lvl="4"/>
             <a:r>
-              <a:rPr lang="en-US" smtClean="0"/>
+              <a:rPr lang="en-US"/>
               <a:t>Fifth level</a:t>
             </a:r>
-            <a:endParaRPr lang="en-US"/>
           </a:p>
         </p:txBody>
       </p:sp>
@@ -2268,7 +2266,7 @@
           <a:p>
             <a:pPr lvl="0"/>
             <a:r>
-              <a:rPr lang="en-US" smtClean="0"/>
+              <a:rPr lang="en-US"/>
               <a:t>Click to edit Master text styles</a:t>
             </a:r>
           </a:p>
@@ -2291,7 +2289,7 @@
           <a:p>
             <a:fld id="{5BCAD085-E8A6-8845-BD4E-CB4CCA059FC4}" type="datetimeFigureOut">
               <a:rPr lang="en-US" smtClean="0"/>
-              <a:t>1/27/13</a:t>
+              <a:t>3/18/2026</a:t>
             </a:fld>
             <a:endParaRPr lang="en-US"/>
           </a:p>
@@ -2394,10 +2392,9 @@
           </a:lstStyle>
           <a:p>
             <a:r>
-              <a:rPr lang="en-US" smtClean="0"/>
+              <a:rPr lang="en-US"/>
               <a:t>Click to edit Master title style</a:t>
             </a:r>
-            <a:endParaRPr lang="en-US"/>
           </a:p>
         </p:txBody>
       </p:sp>
@@ -2521,7 +2518,7 @@
           <a:p>
             <a:pPr lvl="0"/>
             <a:r>
-              <a:rPr lang="en-US" smtClean="0"/>
+              <a:rPr lang="en-US"/>
               <a:t>Click to edit Master text styles</a:t>
             </a:r>
           </a:p>
@@ -2544,7 +2541,7 @@
           <a:p>
             <a:fld id="{5BCAD085-E8A6-8845-BD4E-CB4CCA059FC4}" type="datetimeFigureOut">
               <a:rPr lang="en-US" smtClean="0"/>
-              <a:t>1/27/13</a:t>
+              <a:t>3/18/2026</a:t>
             </a:fld>
             <a:endParaRPr lang="en-US"/>
           </a:p>
@@ -2653,10 +2650,9 @@
           <a:lstStyle/>
           <a:p>
             <a:r>
-              <a:rPr lang="en-US" smtClean="0"/>
+              <a:rPr lang="en-US"/>
               <a:t>Click to edit Master title style</a:t>
             </a:r>
-            <a:endParaRPr lang="en-US"/>
           </a:p>
         </p:txBody>
       </p:sp>
@@ -2687,38 +2683,37 @@
           <a:p>
             <a:pPr lvl="0"/>
             <a:r>
-              <a:rPr lang="en-US" smtClean="0"/>
+              <a:rPr lang="en-US"/>
               <a:t>Click to edit Master text styles</a:t>
             </a:r>
           </a:p>
           <a:p>
             <a:pPr lvl="1"/>
             <a:r>
-              <a:rPr lang="en-US" smtClean="0"/>
+              <a:rPr lang="en-US"/>
               <a:t>Second level</a:t>
             </a:r>
           </a:p>
           <a:p>
             <a:pPr lvl="2"/>
             <a:r>
-              <a:rPr lang="en-US" smtClean="0"/>
+              <a:rPr lang="en-US"/>
               <a:t>Third level</a:t>
             </a:r>
           </a:p>
           <a:p>
             <a:pPr lvl="3"/>
             <a:r>
-              <a:rPr lang="en-US" smtClean="0"/>
+              <a:rPr lang="en-US"/>
               <a:t>Fourth level</a:t>
             </a:r>
           </a:p>
           <a:p>
             <a:pPr lvl="4"/>
             <a:r>
-              <a:rPr lang="en-US" smtClean="0"/>
+              <a:rPr lang="en-US"/>
               <a:t>Fifth level</a:t>
             </a:r>
-            <a:endParaRPr lang="en-US"/>
           </a:p>
         </p:txBody>
       </p:sp>
@@ -2757,7 +2752,7 @@
           <a:p>
             <a:fld id="{5BCAD085-E8A6-8845-BD4E-CB4CCA059FC4}" type="datetimeFigureOut">
               <a:rPr lang="en-US" smtClean="0"/>
-              <a:t>1/27/13</a:t>
+              <a:t>3/18/2026</a:t>
             </a:fld>
             <a:endParaRPr lang="en-US"/>
           </a:p>
@@ -3116,7 +3111,7 @@
 </file>
 
 <file path=ppt/slides/slide1.xml><?xml version="1.0" encoding="utf-8"?>
-<p:sld xmlns:a="http://schemas.openxmlformats.org/drawingml/2006/main" xmlns:p="http://schemas.openxmlformats.org/presentationml/2006/main" xmlns:r="http://schemas.openxmlformats.org/officeDocument/2006/relationships">
+<p:sld xmlns:a="http://schemas.openxmlformats.org/drawingml/2006/main" xmlns:r="http://schemas.openxmlformats.org/officeDocument/2006/relationships" xmlns:p="http://schemas.openxmlformats.org/presentationml/2006/main">
   <p:cSld>
     <p:bg>
       <p:bgPr>
@@ -3132,7 +3127,14 @@
         <p:cNvGrpSpPr/>
         <p:nvPr/>
       </p:nvGrpSpPr>
-      <p:grpSpPr/>
+      <p:grpSpPr>
+        <a:xfrm>
+          <a:off x="0" y="0"/>
+          <a:ext cx="0" cy="0"/>
+          <a:chOff x="0" y="0"/>
+          <a:chExt cx="0" cy="0"/>
+        </a:xfrm>
+      </p:grpSpPr>
       <p:sp>
         <p:nvSpPr>
           <p:cNvPr id="2" name="TextBox 1"/>
@@ -3212,7 +3214,7 @@
 </file>
 
 <file path=ppt/slides/slide10.xml><?xml version="1.0" encoding="utf-8"?>
-<p:sld xmlns:a="http://schemas.openxmlformats.org/drawingml/2006/main" xmlns:p="http://schemas.openxmlformats.org/presentationml/2006/main" xmlns:r="http://schemas.openxmlformats.org/officeDocument/2006/relationships">
+<p:sld xmlns:a="http://schemas.openxmlformats.org/drawingml/2006/main" xmlns:r="http://schemas.openxmlformats.org/officeDocument/2006/relationships" xmlns:p="http://schemas.openxmlformats.org/presentationml/2006/main">
   <p:cSld>
     <p:bg>
       <p:bgPr>
@@ -3228,7 +3230,14 @@
         <p:cNvGrpSpPr/>
         <p:nvPr/>
       </p:nvGrpSpPr>
-      <p:grpSpPr/>
+      <p:grpSpPr>
+        <a:xfrm>
+          <a:off x="0" y="0"/>
+          <a:ext cx="0" cy="0"/>
+          <a:chOff x="0" y="0"/>
+          <a:chExt cx="0" cy="0"/>
+        </a:xfrm>
+      </p:grpSpPr>
       <p:sp>
         <p:nvSpPr>
           <p:cNvPr id="2" name="Oval 1"/>
@@ -3265,7 +3274,7 @@
           </a:fontRef>
         </p:style>
         <p:txBody>
-          <a:bodyPr rtlCol="0" anchor="ctr" wrap="square"/>
+          <a:bodyPr wrap="square" rtlCol="0" anchor="ctr"/>
           <a:lstStyle/>
           <a:p>
             <a:pPr algn="ctr">
@@ -3325,7 +3334,7 @@
 </file>
 
 <file path=ppt/slides/slide11.xml><?xml version="1.0" encoding="utf-8"?>
-<p:sld xmlns:a="http://schemas.openxmlformats.org/drawingml/2006/main" xmlns:p="http://schemas.openxmlformats.org/presentationml/2006/main" xmlns:r="http://schemas.openxmlformats.org/officeDocument/2006/relationships">
+<p:sld xmlns:a="http://schemas.openxmlformats.org/drawingml/2006/main" xmlns:r="http://schemas.openxmlformats.org/officeDocument/2006/relationships" xmlns:p="http://schemas.openxmlformats.org/presentationml/2006/main">
   <p:cSld>
     <p:bg>
       <p:bgPr>
@@ -3341,7 +3350,14 @@
         <p:cNvGrpSpPr/>
         <p:nvPr/>
       </p:nvGrpSpPr>
-      <p:grpSpPr/>
+      <p:grpSpPr>
+        <a:xfrm>
+          <a:off x="0" y="0"/>
+          <a:ext cx="0" cy="0"/>
+          <a:chOff x="0" y="0"/>
+          <a:chExt cx="0" cy="0"/>
+        </a:xfrm>
+      </p:grpSpPr>
       <p:sp>
         <p:nvSpPr>
           <p:cNvPr id="2" name="TextBox 1"/>
@@ -3419,6 +3435,7 @@
           <a:lstStyle/>
           <a:p>
             <a:pPr algn="ctr"/>
+            <a:endParaRPr/>
           </a:p>
         </p:txBody>
       </p:sp>
@@ -3523,6 +3540,7 @@
                 </a:solidFill>
               </a:defRPr>
             </a:pPr>
+            <a:endParaRPr/>
           </a:p>
           <a:p>
             <a:pPr>
@@ -3610,6 +3628,7 @@
                 </a:solidFill>
               </a:defRPr>
             </a:pPr>
+            <a:endParaRPr/>
           </a:p>
           <a:p>
             <a:pPr>
@@ -3679,6 +3698,7 @@
                 </a:solidFill>
               </a:defRPr>
             </a:pPr>
+            <a:endParaRPr/>
           </a:p>
           <a:p>
             <a:pPr>
@@ -3744,7 +3764,7 @@
 </file>
 
 <file path=ppt/slides/slide12.xml><?xml version="1.0" encoding="utf-8"?>
-<p:sld xmlns:a="http://schemas.openxmlformats.org/drawingml/2006/main" xmlns:p="http://schemas.openxmlformats.org/presentationml/2006/main" xmlns:r="http://schemas.openxmlformats.org/officeDocument/2006/relationships">
+<p:sld xmlns:a="http://schemas.openxmlformats.org/drawingml/2006/main" xmlns:r="http://schemas.openxmlformats.org/officeDocument/2006/relationships" xmlns:p="http://schemas.openxmlformats.org/presentationml/2006/main">
   <p:cSld>
     <p:bg>
       <p:bgPr>
@@ -3760,7 +3780,14 @@
         <p:cNvGrpSpPr/>
         <p:nvPr/>
       </p:nvGrpSpPr>
-      <p:grpSpPr/>
+      <p:grpSpPr>
+        <a:xfrm>
+          <a:off x="0" y="0"/>
+          <a:ext cx="0" cy="0"/>
+          <a:chOff x="0" y="0"/>
+          <a:chExt cx="0" cy="0"/>
+        </a:xfrm>
+      </p:grpSpPr>
       <p:sp>
         <p:nvSpPr>
           <p:cNvPr id="2" name="TextBox 1"/>
@@ -3838,6 +3865,7 @@
           <a:lstStyle/>
           <a:p>
             <a:pPr algn="ctr"/>
+            <a:endParaRPr/>
           </a:p>
         </p:txBody>
       </p:sp>
@@ -3850,7 +3878,7 @@
         <p:spPr>
           <a:xfrm>
             <a:off x="640080" y="1188720"/>
-            <a:ext cx="10972800" cy="4754880"/>
+            <a:ext cx="10972800" cy="4765407"/>
           </a:xfrm>
           <a:prstGeom prst="rect">
             <a:avLst/>
@@ -3871,7 +3899,20 @@
               </a:defRPr>
             </a:pPr>
             <a:r>
-              <a:t>設定專案 ID（自動前綴 commit message）</a:t>
+              <a:rPr dirty="0" err="1"/>
+              <a:t>設定專案</a:t>
+            </a:r>
+            <a:r>
+              <a:rPr dirty="0"/>
+              <a:t> </a:t>
+            </a:r>
+            <a:r>
+              <a:rPr dirty="0" err="1"/>
+              <a:t>ID（自動前綴</a:t>
+            </a:r>
+            <a:r>
+              <a:rPr dirty="0"/>
+              <a:t> commit message）</a:t>
             </a:r>
           </a:p>
           <a:p>
@@ -3889,7 +3930,16 @@
               </a:defRPr>
             </a:pPr>
             <a:r>
-              <a:t>$ ai-review config set commit project_id "PROJ-1"</a:t>
+              <a:rPr dirty="0"/>
+              <a:t>$ ai-review config set commit </a:t>
+            </a:r>
+            <a:r>
+              <a:rPr dirty="0" err="1"/>
+              <a:t>project_id</a:t>
+            </a:r>
+            <a:r>
+              <a:rPr dirty="0"/>
+              <a:t> "PROJ-1"</a:t>
             </a:r>
           </a:p>
           <a:p>
@@ -3906,6 +3956,7 @@
                 </a:solidFill>
               </a:defRPr>
             </a:pPr>
+            <a:endParaRPr dirty="0"/>
           </a:p>
           <a:p>
             <a:pPr>
@@ -3922,8 +3973,18 @@
               </a:defRPr>
             </a:pPr>
             <a:r>
-              <a:t>初始化 commit 模板</a:t>
-            </a:r>
+              <a:rPr dirty="0" err="1"/>
+              <a:t>初始化</a:t>
+            </a:r>
+            <a:r>
+              <a:rPr dirty="0"/>
+              <a:t> commit </a:t>
+            </a:r>
+            <a:r>
+              <a:rPr dirty="0" err="1"/>
+              <a:t>模板</a:t>
+            </a:r>
+            <a:endParaRPr dirty="0"/>
           </a:p>
           <a:p>
             <a:pPr lvl="1">
@@ -3940,8 +4001,18 @@
               </a:defRPr>
             </a:pPr>
             <a:r>
-              <a:t>$ ai-review config init-template</a:t>
-            </a:r>
+              <a:rPr dirty="0"/>
+              <a:t>$ ai-review config </a:t>
+            </a:r>
+            <a:r>
+              <a:rPr dirty="0" err="1"/>
+              <a:t>init</a:t>
+            </a:r>
+            <a:r>
+              <a:rPr dirty="0"/>
+              <a:t>-template</a:t>
+            </a:r>
+            <a:endParaRPr lang="en-US" dirty="0"/>
           </a:p>
           <a:p>
             <a:pPr lvl="1">
@@ -3953,13 +4024,197 @@
               </a:spcAft>
               <a:defRPr sz="1400" b="0">
                 <a:solidFill>
+                  <a:srgbClr val="A6E3A1"/>
+                </a:solidFill>
+              </a:defRPr>
+            </a:pPr>
+            <a:r>
+              <a:rPr lang="zh-TW" altLang="en-US" dirty="0"/>
+              <a:t>模板檔會複製到 </a:t>
+            </a:r>
+            <a:r>
+              <a:rPr lang="en-US" altLang="zh-TW"/>
+              <a:t>~/.config/ai-code-review/commit-template.txt</a:t>
+            </a:r>
+            <a:endParaRPr lang="en-US" dirty="0"/>
+          </a:p>
+          <a:p>
+            <a:pPr marL="0" lvl="1">
+              <a:spcBef>
+                <a:spcPts val="600"/>
+              </a:spcBef>
+              <a:spcAft>
+                <a:spcPts val="200"/>
+              </a:spcAft>
+              <a:defRPr sz="1800" b="1">
+                <a:solidFill>
+                  <a:srgbClr val="CDD6F4"/>
+                </a:solidFill>
+              </a:defRPr>
+            </a:pPr>
+            <a:r>
+              <a:rPr lang="zh-TW" altLang="en-US" b="1" dirty="0">
+                <a:solidFill>
+                  <a:srgbClr val="CDD6F4"/>
+                </a:solidFill>
+              </a:rPr>
+              <a:t>初始化 </a:t>
+            </a:r>
+            <a:r>
+              <a:rPr lang="it-IT" altLang="zh-TW" b="1" dirty="0">
+                <a:solidFill>
+                  <a:srgbClr val="CDD6F4"/>
+                </a:solidFill>
+              </a:rPr>
+              <a:t>AI </a:t>
+            </a:r>
+            <a:r>
+              <a:rPr lang="zh-TW" altLang="en-US" b="1" dirty="0">
+                <a:solidFill>
+                  <a:srgbClr val="CDD6F4"/>
+                </a:solidFill>
+              </a:rPr>
+              <a:t>生成 </a:t>
+            </a:r>
+            <a:r>
+              <a:rPr lang="it-IT" altLang="zh-TW" b="1" dirty="0">
+                <a:solidFill>
+                  <a:srgbClr val="CDD6F4"/>
+                </a:solidFill>
+              </a:rPr>
+              <a:t>prompt |</a:t>
+            </a:r>
+            <a:endParaRPr lang="en-US" b="1" dirty="0">
+              <a:solidFill>
+                <a:srgbClr val="CDD6F4"/>
+              </a:solidFill>
+            </a:endParaRPr>
+          </a:p>
+          <a:p>
+            <a:pPr lvl="1">
+              <a:spcBef>
+                <a:spcPts val="600"/>
+              </a:spcBef>
+              <a:spcAft>
+                <a:spcPts val="200"/>
+              </a:spcAft>
+              <a:defRPr sz="1400" b="0">
+                <a:solidFill>
+                  <a:srgbClr val="A6E3A1"/>
+                </a:solidFill>
+              </a:defRPr>
+            </a:pPr>
+            <a:r>
+              <a:rPr lang="en-US" altLang="zh-TW" dirty="0"/>
+              <a:t>$ </a:t>
+            </a:r>
+            <a:r>
+              <a:rPr lang="it-IT" dirty="0"/>
+              <a:t>ai-review config init-generate-prompt</a:t>
+            </a:r>
+            <a:endParaRPr dirty="0"/>
+          </a:p>
+          <a:p>
+            <a:pPr>
+              <a:spcBef>
+                <a:spcPts val="600"/>
+              </a:spcBef>
+              <a:spcAft>
+                <a:spcPts val="200"/>
+              </a:spcAft>
+              <a:defRPr sz="800" b="0">
+                <a:solidFill>
+                  <a:srgbClr val="CDD6F4"/>
+                </a:solidFill>
+              </a:defRPr>
+            </a:pPr>
+            <a:endParaRPr dirty="0"/>
+          </a:p>
+          <a:p>
+            <a:pPr>
+              <a:spcBef>
+                <a:spcPts val="600"/>
+              </a:spcBef>
+              <a:spcAft>
+                <a:spcPts val="200"/>
+              </a:spcAft>
+              <a:defRPr sz="1800" b="1">
+                <a:solidFill>
+                  <a:srgbClr val="CDD6F4"/>
+                </a:solidFill>
+              </a:defRPr>
+            </a:pPr>
+            <a:r>
+              <a:rPr dirty="0" err="1"/>
+              <a:t>限縮審查副檔名（預設：不限制，審查所有檔案</a:t>
+            </a:r>
+            <a:r>
+              <a:rPr dirty="0"/>
+              <a:t>）</a:t>
+            </a:r>
+          </a:p>
+          <a:p>
+            <a:pPr lvl="1">
+              <a:spcBef>
+                <a:spcPts val="600"/>
+              </a:spcBef>
+              <a:spcAft>
+                <a:spcPts val="200"/>
+              </a:spcAft>
+              <a:defRPr sz="1400" b="0">
+                <a:solidFill>
+                  <a:srgbClr val="A6E3A1"/>
+                </a:solidFill>
+              </a:defRPr>
+            </a:pPr>
+            <a:r>
+              <a:rPr dirty="0"/>
+              <a:t>$ ai-review config set review </a:t>
+            </a:r>
+            <a:r>
+              <a:rPr dirty="0" err="1"/>
+              <a:t>include_extensions</a:t>
+            </a:r>
+            <a:r>
+              <a:rPr dirty="0"/>
+              <a:t> "</a:t>
+            </a:r>
+            <a:r>
+              <a:rPr dirty="0" err="1"/>
+              <a:t>c,cpp,h,py</a:t>
+            </a:r>
+            <a:r>
+              <a:rPr dirty="0"/>
+              <a:t>"</a:t>
+            </a:r>
+          </a:p>
+          <a:p>
+            <a:pPr lvl="1">
+              <a:spcBef>
+                <a:spcPts val="600"/>
+              </a:spcBef>
+              <a:spcAft>
+                <a:spcPts val="200"/>
+              </a:spcAft>
+              <a:defRPr sz="1400" b="0">
+                <a:solidFill>
                   <a:srgbClr val="6C7086"/>
                 </a:solidFill>
               </a:defRPr>
             </a:pPr>
             <a:r>
-              <a:t>模板檔會複製到 ~/.config/ai-code-review/commit-template.txt</a:t>
-            </a:r>
+              <a:rPr dirty="0" err="1"/>
+              <a:t>預設：空（全部檔案</a:t>
+            </a:r>
+            <a:r>
+              <a:rPr dirty="0"/>
+              <a:t>），</a:t>
+            </a:r>
+            <a:r>
+              <a:rPr dirty="0" err="1"/>
+              <a:t>有需要時再設定限縮</a:t>
+            </a:r>
+            <a:endParaRPr dirty="0"/>
           </a:p>
           <a:p>
             <a:pPr>
@@ -3975,6 +4230,7 @@
                 </a:solidFill>
               </a:defRPr>
             </a:pPr>
+            <a:endParaRPr dirty="0"/>
           </a:p>
           <a:p>
             <a:pPr>
@@ -3991,8 +4247,10 @@
               </a:defRPr>
             </a:pPr>
             <a:r>
-              <a:t>限縮審查副檔名（預設：不限制，審查所有檔案）</a:t>
-            </a:r>
+              <a:rPr dirty="0" err="1"/>
+              <a:t>驗證設定</a:t>
+            </a:r>
+            <a:endParaRPr dirty="0"/>
           </a:p>
           <a:p>
             <a:pPr lvl="1">
@@ -4009,75 +4267,7 @@
               </a:defRPr>
             </a:pPr>
             <a:r>
-              <a:t>$ ai-review config set review include_extensions "c,cpp,h,py"</a:t>
-            </a:r>
-          </a:p>
-          <a:p>
-            <a:pPr lvl="1">
-              <a:spcBef>
-                <a:spcPts val="600"/>
-              </a:spcBef>
-              <a:spcAft>
-                <a:spcPts val="200"/>
-              </a:spcAft>
-              <a:defRPr sz="1400" b="0">
-                <a:solidFill>
-                  <a:srgbClr val="6C7086"/>
-                </a:solidFill>
-              </a:defRPr>
-            </a:pPr>
-            <a:r>
-              <a:t>預設：空（全部檔案），有需要時再設定限縮</a:t>
-            </a:r>
-          </a:p>
-          <a:p>
-            <a:pPr>
-              <a:spcBef>
-                <a:spcPts val="600"/>
-              </a:spcBef>
-              <a:spcAft>
-                <a:spcPts val="200"/>
-              </a:spcAft>
-              <a:defRPr sz="800" b="0">
-                <a:solidFill>
-                  <a:srgbClr val="CDD6F4"/>
-                </a:solidFill>
-              </a:defRPr>
-            </a:pPr>
-          </a:p>
-          <a:p>
-            <a:pPr>
-              <a:spcBef>
-                <a:spcPts val="600"/>
-              </a:spcBef>
-              <a:spcAft>
-                <a:spcPts val="200"/>
-              </a:spcAft>
-              <a:defRPr sz="1800" b="1">
-                <a:solidFill>
-                  <a:srgbClr val="CDD6F4"/>
-                </a:solidFill>
-              </a:defRPr>
-            </a:pPr>
-            <a:r>
-              <a:t>驗證設定</a:t>
-            </a:r>
-          </a:p>
-          <a:p>
-            <a:pPr lvl="1">
-              <a:spcBef>
-                <a:spcPts val="600"/>
-              </a:spcBef>
-              <a:spcAft>
-                <a:spcPts val="200"/>
-              </a:spcAft>
-              <a:defRPr sz="1400" b="0">
-                <a:solidFill>
-                  <a:srgbClr val="A6E3A1"/>
-                </a:solidFill>
-              </a:defRPr>
-            </a:pPr>
-            <a:r>
+              <a:rPr dirty="0"/>
               <a:t>$ ai-review config show</a:t>
             </a:r>
           </a:p>
@@ -4092,7 +4282,7 @@
 </file>
 
 <file path=ppt/slides/slide13.xml><?xml version="1.0" encoding="utf-8"?>
-<p:sld xmlns:a="http://schemas.openxmlformats.org/drawingml/2006/main" xmlns:p="http://schemas.openxmlformats.org/presentationml/2006/main" xmlns:r="http://schemas.openxmlformats.org/officeDocument/2006/relationships">
+<p:sld xmlns:a="http://schemas.openxmlformats.org/drawingml/2006/main" xmlns:r="http://schemas.openxmlformats.org/officeDocument/2006/relationships" xmlns:p="http://schemas.openxmlformats.org/presentationml/2006/main">
   <p:cSld>
     <p:bg>
       <p:bgPr>
@@ -4108,7 +4298,14 @@
         <p:cNvGrpSpPr/>
         <p:nvPr/>
       </p:nvGrpSpPr>
-      <p:grpSpPr/>
+      <p:grpSpPr>
+        <a:xfrm>
+          <a:off x="0" y="0"/>
+          <a:ext cx="0" cy="0"/>
+          <a:chOff x="0" y="0"/>
+          <a:chExt cx="0" cy="0"/>
+        </a:xfrm>
+      </p:grpSpPr>
       <p:sp>
         <p:nvSpPr>
           <p:cNvPr id="2" name="Oval 1"/>
@@ -4145,7 +4342,7 @@
           </a:fontRef>
         </p:style>
         <p:txBody>
-          <a:bodyPr rtlCol="0" anchor="ctr" wrap="square"/>
+          <a:bodyPr wrap="square" rtlCol="0" anchor="ctr"/>
           <a:lstStyle/>
           <a:p>
             <a:pPr algn="ctr">
@@ -4205,7 +4402,7 @@
 </file>
 
 <file path=ppt/slides/slide14.xml><?xml version="1.0" encoding="utf-8"?>
-<p:sld xmlns:a="http://schemas.openxmlformats.org/drawingml/2006/main" xmlns:p="http://schemas.openxmlformats.org/presentationml/2006/main" xmlns:r="http://schemas.openxmlformats.org/officeDocument/2006/relationships">
+<p:sld xmlns:a="http://schemas.openxmlformats.org/drawingml/2006/main" xmlns:r="http://schemas.openxmlformats.org/officeDocument/2006/relationships" xmlns:p="http://schemas.openxmlformats.org/presentationml/2006/main">
   <p:cSld>
     <p:bg>
       <p:bgPr>
@@ -4221,7 +4418,14 @@
         <p:cNvGrpSpPr/>
         <p:nvPr/>
       </p:nvGrpSpPr>
-      <p:grpSpPr/>
+      <p:grpSpPr>
+        <a:xfrm>
+          <a:off x="0" y="0"/>
+          <a:ext cx="0" cy="0"/>
+          <a:chOff x="0" y="0"/>
+          <a:chExt cx="0" cy="0"/>
+        </a:xfrm>
+      </p:grpSpPr>
       <p:sp>
         <p:nvSpPr>
           <p:cNvPr id="2" name="TextBox 1"/>
@@ -4299,6 +4503,7 @@
           <a:lstStyle/>
           <a:p>
             <a:pPr algn="ctr"/>
+            <a:endParaRPr/>
           </a:p>
         </p:txBody>
       </p:sp>
@@ -4403,6 +4608,7 @@
                 </a:solidFill>
               </a:defRPr>
             </a:pPr>
+            <a:endParaRPr/>
           </a:p>
           <a:p>
             <a:pPr>
@@ -4508,6 +4714,7 @@
                 </a:solidFill>
               </a:defRPr>
             </a:pPr>
+            <a:endParaRPr/>
           </a:p>
           <a:p>
             <a:pPr>
@@ -4573,7 +4780,7 @@
 </file>
 
 <file path=ppt/slides/slide15.xml><?xml version="1.0" encoding="utf-8"?>
-<p:sld xmlns:a="http://schemas.openxmlformats.org/drawingml/2006/main" xmlns:p="http://schemas.openxmlformats.org/presentationml/2006/main" xmlns:r="http://schemas.openxmlformats.org/officeDocument/2006/relationships">
+<p:sld xmlns:a="http://schemas.openxmlformats.org/drawingml/2006/main" xmlns:r="http://schemas.openxmlformats.org/officeDocument/2006/relationships" xmlns:p="http://schemas.openxmlformats.org/presentationml/2006/main">
   <p:cSld>
     <p:bg>
       <p:bgPr>
@@ -4589,7 +4796,14 @@
         <p:cNvGrpSpPr/>
         <p:nvPr/>
       </p:nvGrpSpPr>
-      <p:grpSpPr/>
+      <p:grpSpPr>
+        <a:xfrm>
+          <a:off x="0" y="0"/>
+          <a:ext cx="0" cy="0"/>
+          <a:chOff x="0" y="0"/>
+          <a:chExt cx="0" cy="0"/>
+        </a:xfrm>
+      </p:grpSpPr>
       <p:sp>
         <p:nvSpPr>
           <p:cNvPr id="2" name="TextBox 1"/>
@@ -4644,10 +4858,34 @@
                 <a:tableStyleId>{5C22544A-7EE6-4342-B048-85BDC9FD1C3A}</a:tableStyleId>
               </a:tblPr>
               <a:tblGrid>
-                <a:gridCol w="2743200"/>
-                <a:gridCol w="2743200"/>
-                <a:gridCol w="2743200"/>
-                <a:gridCol w="2743200"/>
+                <a:gridCol w="2743200">
+                  <a:extLst>
+                    <a:ext uri="{9D8B030D-6E8A-4147-A177-3AD203B41FA5}">
+                      <a16:colId xmlns:a16="http://schemas.microsoft.com/office/drawing/2014/main" val="20000"/>
+                    </a:ext>
+                  </a:extLst>
+                </a:gridCol>
+                <a:gridCol w="2743200">
+                  <a:extLst>
+                    <a:ext uri="{9D8B030D-6E8A-4147-A177-3AD203B41FA5}">
+                      <a16:colId xmlns:a16="http://schemas.microsoft.com/office/drawing/2014/main" val="20001"/>
+                    </a:ext>
+                  </a:extLst>
+                </a:gridCol>
+                <a:gridCol w="2743200">
+                  <a:extLst>
+                    <a:ext uri="{9D8B030D-6E8A-4147-A177-3AD203B41FA5}">
+                      <a16:colId xmlns:a16="http://schemas.microsoft.com/office/drawing/2014/main" val="20002"/>
+                    </a:ext>
+                  </a:extLst>
+                </a:gridCol>
+                <a:gridCol w="2743200">
+                  <a:extLst>
+                    <a:ext uri="{9D8B030D-6E8A-4147-A177-3AD203B41FA5}">
+                      <a16:colId xmlns:a16="http://schemas.microsoft.com/office/drawing/2014/main" val="20003"/>
+                    </a:ext>
+                  </a:extLst>
+                </a:gridCol>
               </a:tblGrid>
               <a:tr h="548640">
                 <a:tc>
@@ -4742,6 +4980,11 @@
                     </a:solidFill>
                   </a:tcPr>
                 </a:tc>
+                <a:extLst>
+                  <a:ext uri="{0D108BD9-81ED-4DB2-BD59-A6C34878D82A}">
+                    <a16:rowId xmlns:a16="http://schemas.microsoft.com/office/drawing/2014/main" val="10000"/>
+                  </a:ext>
+                </a:extLst>
               </a:tr>
               <a:tr h="548640">
                 <a:tc>
@@ -4836,6 +5079,11 @@
                     </a:solidFill>
                   </a:tcPr>
                 </a:tc>
+                <a:extLst>
+                  <a:ext uri="{0D108BD9-81ED-4DB2-BD59-A6C34878D82A}">
+                    <a16:rowId xmlns:a16="http://schemas.microsoft.com/office/drawing/2014/main" val="10001"/>
+                  </a:ext>
+                </a:extLst>
               </a:tr>
               <a:tr h="548640">
                 <a:tc>
@@ -4930,6 +5178,11 @@
                     </a:solidFill>
                   </a:tcPr>
                 </a:tc>
+                <a:extLst>
+                  <a:ext uri="{0D108BD9-81ED-4DB2-BD59-A6C34878D82A}">
+                    <a16:rowId xmlns:a16="http://schemas.microsoft.com/office/drawing/2014/main" val="10002"/>
+                  </a:ext>
+                </a:extLst>
               </a:tr>
               <a:tr h="548640">
                 <a:tc>
@@ -5024,6 +5277,11 @@
                     </a:solidFill>
                   </a:tcPr>
                 </a:tc>
+                <a:extLst>
+                  <a:ext uri="{0D108BD9-81ED-4DB2-BD59-A6C34878D82A}">
+                    <a16:rowId xmlns:a16="http://schemas.microsoft.com/office/drawing/2014/main" val="10003"/>
+                  </a:ext>
+                </a:extLst>
               </a:tr>
               <a:tr h="548640">
                 <a:tc>
@@ -5118,6 +5376,11 @@
                     </a:solidFill>
                   </a:tcPr>
                 </a:tc>
+                <a:extLst>
+                  <a:ext uri="{0D108BD9-81ED-4DB2-BD59-A6C34878D82A}">
+                    <a16:rowId xmlns:a16="http://schemas.microsoft.com/office/drawing/2014/main" val="10004"/>
+                  </a:ext>
+                </a:extLst>
               </a:tr>
             </a:tbl>
           </a:graphicData>
@@ -5132,7 +5395,7 @@
 </file>
 
 <file path=ppt/slides/slide16.xml><?xml version="1.0" encoding="utf-8"?>
-<p:sld xmlns:a="http://schemas.openxmlformats.org/drawingml/2006/main" xmlns:p="http://schemas.openxmlformats.org/presentationml/2006/main" xmlns:r="http://schemas.openxmlformats.org/officeDocument/2006/relationships">
+<p:sld xmlns:a="http://schemas.openxmlformats.org/drawingml/2006/main" xmlns:r="http://schemas.openxmlformats.org/officeDocument/2006/relationships" xmlns:p="http://schemas.openxmlformats.org/presentationml/2006/main">
   <p:cSld>
     <p:bg>
       <p:bgPr>
@@ -5148,7 +5411,14 @@
         <p:cNvGrpSpPr/>
         <p:nvPr/>
       </p:nvGrpSpPr>
-      <p:grpSpPr/>
+      <p:grpSpPr>
+        <a:xfrm>
+          <a:off x="0" y="0"/>
+          <a:ext cx="0" cy="0"/>
+          <a:chOff x="0" y="0"/>
+          <a:chExt cx="0" cy="0"/>
+        </a:xfrm>
+      </p:grpSpPr>
       <p:sp>
         <p:nvSpPr>
           <p:cNvPr id="2" name="Oval 1"/>
@@ -5185,7 +5455,7 @@
           </a:fontRef>
         </p:style>
         <p:txBody>
-          <a:bodyPr rtlCol="0" anchor="ctr" wrap="square"/>
+          <a:bodyPr wrap="square" rtlCol="0" anchor="ctr"/>
           <a:lstStyle/>
           <a:p>
             <a:pPr algn="ctr">
@@ -5245,7 +5515,7 @@
 </file>
 
 <file path=ppt/slides/slide17.xml><?xml version="1.0" encoding="utf-8"?>
-<p:sld xmlns:a="http://schemas.openxmlformats.org/drawingml/2006/main" xmlns:p="http://schemas.openxmlformats.org/presentationml/2006/main" xmlns:r="http://schemas.openxmlformats.org/officeDocument/2006/relationships">
+<p:sld xmlns:a="http://schemas.openxmlformats.org/drawingml/2006/main" xmlns:r="http://schemas.openxmlformats.org/officeDocument/2006/relationships" xmlns:p="http://schemas.openxmlformats.org/presentationml/2006/main">
   <p:cSld>
     <p:bg>
       <p:bgPr>
@@ -5261,7 +5531,14 @@
         <p:cNvGrpSpPr/>
         <p:nvPr/>
       </p:nvGrpSpPr>
-      <p:grpSpPr/>
+      <p:grpSpPr>
+        <a:xfrm>
+          <a:off x="0" y="0"/>
+          <a:ext cx="0" cy="0"/>
+          <a:chOff x="0" y="0"/>
+          <a:chExt cx="0" cy="0"/>
+        </a:xfrm>
+      </p:grpSpPr>
       <p:sp>
         <p:nvSpPr>
           <p:cNvPr id="2" name="TextBox 1"/>
@@ -5339,6 +5616,7 @@
           <a:lstStyle/>
           <a:p>
             <a:pPr algn="ctr"/>
+            <a:endParaRPr/>
           </a:p>
         </p:txBody>
       </p:sp>
@@ -5389,6 +5667,7 @@
                 </a:solidFill>
               </a:defRPr>
             </a:pPr>
+            <a:endParaRPr/>
           </a:p>
           <a:p>
             <a:pPr>
@@ -5530,6 +5809,7 @@
                 </a:solidFill>
               </a:defRPr>
             </a:pPr>
+            <a:endParaRPr/>
           </a:p>
           <a:p>
             <a:pPr>
@@ -5581,6 +5861,7 @@
                 </a:solidFill>
               </a:defRPr>
             </a:pPr>
+            <a:endParaRPr/>
           </a:p>
           <a:p>
             <a:pPr>
@@ -5629,7 +5910,7 @@
 </file>
 
 <file path=ppt/slides/slide18.xml><?xml version="1.0" encoding="utf-8"?>
-<p:sld xmlns:a="http://schemas.openxmlformats.org/drawingml/2006/main" xmlns:p="http://schemas.openxmlformats.org/presentationml/2006/main" xmlns:r="http://schemas.openxmlformats.org/officeDocument/2006/relationships">
+<p:sld xmlns:a="http://schemas.openxmlformats.org/drawingml/2006/main" xmlns:r="http://schemas.openxmlformats.org/officeDocument/2006/relationships" xmlns:p="http://schemas.openxmlformats.org/presentationml/2006/main">
   <p:cSld>
     <p:bg>
       <p:bgPr>
@@ -5645,7 +5926,14 @@
         <p:cNvGrpSpPr/>
         <p:nvPr/>
       </p:nvGrpSpPr>
-      <p:grpSpPr/>
+      <p:grpSpPr>
+        <a:xfrm>
+          <a:off x="0" y="0"/>
+          <a:ext cx="0" cy="0"/>
+          <a:chOff x="0" y="0"/>
+          <a:chExt cx="0" cy="0"/>
+        </a:xfrm>
+      </p:grpSpPr>
       <p:sp>
         <p:nvSpPr>
           <p:cNvPr id="2" name="Oval 1"/>
@@ -5682,7 +5970,7 @@
           </a:fontRef>
         </p:style>
         <p:txBody>
-          <a:bodyPr rtlCol="0" anchor="ctr" wrap="square"/>
+          <a:bodyPr wrap="square" rtlCol="0" anchor="ctr"/>
           <a:lstStyle/>
           <a:p>
             <a:pPr algn="ctr">
@@ -5742,7 +6030,7 @@
 </file>
 
 <file path=ppt/slides/slide19.xml><?xml version="1.0" encoding="utf-8"?>
-<p:sld xmlns:a="http://schemas.openxmlformats.org/drawingml/2006/main" xmlns:p="http://schemas.openxmlformats.org/presentationml/2006/main" xmlns:r="http://schemas.openxmlformats.org/officeDocument/2006/relationships">
+<p:sld xmlns:a="http://schemas.openxmlformats.org/drawingml/2006/main" xmlns:r="http://schemas.openxmlformats.org/officeDocument/2006/relationships" xmlns:p="http://schemas.openxmlformats.org/presentationml/2006/main">
   <p:cSld>
     <p:bg>
       <p:bgPr>
@@ -5758,7 +6046,14 @@
         <p:cNvGrpSpPr/>
         <p:nvPr/>
       </p:nvGrpSpPr>
-      <p:grpSpPr/>
+      <p:grpSpPr>
+        <a:xfrm>
+          <a:off x="0" y="0"/>
+          <a:ext cx="0" cy="0"/>
+          <a:chOff x="0" y="0"/>
+          <a:chExt cx="0" cy="0"/>
+        </a:xfrm>
+      </p:grpSpPr>
       <p:sp>
         <p:nvSpPr>
           <p:cNvPr id="2" name="TextBox 1"/>
@@ -5836,6 +6131,7 @@
           <a:lstStyle/>
           <a:p>
             <a:pPr algn="ctr"/>
+            <a:endParaRPr/>
           </a:p>
         </p:txBody>
       </p:sp>
@@ -5886,6 +6182,7 @@
                 </a:solidFill>
               </a:defRPr>
             </a:pPr>
+            <a:endParaRPr/>
           </a:p>
           <a:p>
             <a:pPr>
@@ -5991,6 +6288,7 @@
                 </a:solidFill>
               </a:defRPr>
             </a:pPr>
+            <a:endParaRPr/>
           </a:p>
           <a:p>
             <a:pPr>
@@ -6078,6 +6376,7 @@
                 </a:solidFill>
               </a:defRPr>
             </a:pPr>
+            <a:endParaRPr/>
           </a:p>
           <a:p>
             <a:pPr>
@@ -6108,7 +6407,7 @@
 </file>
 
 <file path=ppt/slides/slide2.xml><?xml version="1.0" encoding="utf-8"?>
-<p:sld xmlns:a="http://schemas.openxmlformats.org/drawingml/2006/main" xmlns:p="http://schemas.openxmlformats.org/presentationml/2006/main" xmlns:r="http://schemas.openxmlformats.org/officeDocument/2006/relationships">
+<p:sld xmlns:a="http://schemas.openxmlformats.org/drawingml/2006/main" xmlns:r="http://schemas.openxmlformats.org/officeDocument/2006/relationships" xmlns:p="http://schemas.openxmlformats.org/presentationml/2006/main">
   <p:cSld>
     <p:bg>
       <p:bgPr>
@@ -6124,7 +6423,14 @@
         <p:cNvGrpSpPr/>
         <p:nvPr/>
       </p:nvGrpSpPr>
-      <p:grpSpPr/>
+      <p:grpSpPr>
+        <a:xfrm>
+          <a:off x="0" y="0"/>
+          <a:ext cx="0" cy="0"/>
+          <a:chOff x="0" y="0"/>
+          <a:chExt cx="0" cy="0"/>
+        </a:xfrm>
+      </p:grpSpPr>
       <p:sp>
         <p:nvSpPr>
           <p:cNvPr id="2" name="TextBox 1"/>
@@ -6202,6 +6508,7 @@
           <a:lstStyle/>
           <a:p>
             <a:pPr algn="ctr"/>
+            <a:endParaRPr/>
           </a:p>
         </p:txBody>
       </p:sp>
@@ -6447,7 +6754,7 @@
 </file>
 
 <file path=ppt/slides/slide20.xml><?xml version="1.0" encoding="utf-8"?>
-<p:sld xmlns:a="http://schemas.openxmlformats.org/drawingml/2006/main" xmlns:p="http://schemas.openxmlformats.org/presentationml/2006/main" xmlns:r="http://schemas.openxmlformats.org/officeDocument/2006/relationships">
+<p:sld xmlns:a="http://schemas.openxmlformats.org/drawingml/2006/main" xmlns:r="http://schemas.openxmlformats.org/officeDocument/2006/relationships" xmlns:p="http://schemas.openxmlformats.org/presentationml/2006/main">
   <p:cSld>
     <p:bg>
       <p:bgPr>
@@ -6463,7 +6770,14 @@
         <p:cNvGrpSpPr/>
         <p:nvPr/>
       </p:nvGrpSpPr>
-      <p:grpSpPr/>
+      <p:grpSpPr>
+        <a:xfrm>
+          <a:off x="0" y="0"/>
+          <a:ext cx="0" cy="0"/>
+          <a:chOff x="0" y="0"/>
+          <a:chExt cx="0" cy="0"/>
+        </a:xfrm>
+      </p:grpSpPr>
       <p:sp>
         <p:nvSpPr>
           <p:cNvPr id="2" name="Oval 1"/>
@@ -6500,7 +6814,7 @@
           </a:fontRef>
         </p:style>
         <p:txBody>
-          <a:bodyPr rtlCol="0" anchor="ctr" wrap="square"/>
+          <a:bodyPr wrap="square" rtlCol="0" anchor="ctr"/>
           <a:lstStyle/>
           <a:p>
             <a:pPr algn="ctr">
@@ -6560,7 +6874,7 @@
 </file>
 
 <file path=ppt/slides/slide21.xml><?xml version="1.0" encoding="utf-8"?>
-<p:sld xmlns:a="http://schemas.openxmlformats.org/drawingml/2006/main" xmlns:p="http://schemas.openxmlformats.org/presentationml/2006/main" xmlns:r="http://schemas.openxmlformats.org/officeDocument/2006/relationships">
+<p:sld xmlns:a="http://schemas.openxmlformats.org/drawingml/2006/main" xmlns:r="http://schemas.openxmlformats.org/officeDocument/2006/relationships" xmlns:p="http://schemas.openxmlformats.org/presentationml/2006/main">
   <p:cSld>
     <p:bg>
       <p:bgPr>
@@ -6576,7 +6890,14 @@
         <p:cNvGrpSpPr/>
         <p:nvPr/>
       </p:nvGrpSpPr>
-      <p:grpSpPr/>
+      <p:grpSpPr>
+        <a:xfrm>
+          <a:off x="0" y="0"/>
+          <a:ext cx="0" cy="0"/>
+          <a:chOff x="0" y="0"/>
+          <a:chExt cx="0" cy="0"/>
+        </a:xfrm>
+      </p:grpSpPr>
       <p:sp>
         <p:nvSpPr>
           <p:cNvPr id="2" name="TextBox 1"/>
@@ -6654,6 +6975,7 @@
           <a:lstStyle/>
           <a:p>
             <a:pPr algn="ctr"/>
+            <a:endParaRPr/>
           </a:p>
         </p:txBody>
       </p:sp>
@@ -6776,6 +7098,7 @@
                 </a:solidFill>
               </a:defRPr>
             </a:pPr>
+            <a:endParaRPr/>
           </a:p>
           <a:p>
             <a:pPr>
@@ -6896,7 +7219,7 @@
 </file>
 
 <file path=ppt/slides/slide22.xml><?xml version="1.0" encoding="utf-8"?>
-<p:sld xmlns:a="http://schemas.openxmlformats.org/drawingml/2006/main" xmlns:p="http://schemas.openxmlformats.org/presentationml/2006/main" xmlns:r="http://schemas.openxmlformats.org/officeDocument/2006/relationships">
+<p:sld xmlns:a="http://schemas.openxmlformats.org/drawingml/2006/main" xmlns:r="http://schemas.openxmlformats.org/officeDocument/2006/relationships" xmlns:p="http://schemas.openxmlformats.org/presentationml/2006/main">
   <p:cSld>
     <p:bg>
       <p:bgPr>
@@ -6912,7 +7235,14 @@
         <p:cNvGrpSpPr/>
         <p:nvPr/>
       </p:nvGrpSpPr>
-      <p:grpSpPr/>
+      <p:grpSpPr>
+        <a:xfrm>
+          <a:off x="0" y="0"/>
+          <a:ext cx="0" cy="0"/>
+          <a:chOff x="0" y="0"/>
+          <a:chExt cx="0" cy="0"/>
+        </a:xfrm>
+      </p:grpSpPr>
       <p:sp>
         <p:nvSpPr>
           <p:cNvPr id="2" name="TextBox 1"/>
@@ -6990,6 +7320,7 @@
           <a:lstStyle/>
           <a:p>
             <a:pPr algn="ctr"/>
+            <a:endParaRPr/>
           </a:p>
         </p:txBody>
       </p:sp>
@@ -7094,6 +7425,7 @@
                 </a:solidFill>
               </a:defRPr>
             </a:pPr>
+            <a:endParaRPr/>
           </a:p>
           <a:p>
             <a:pPr>
@@ -7145,6 +7477,7 @@
                 </a:solidFill>
               </a:defRPr>
             </a:pPr>
+            <a:endParaRPr/>
           </a:p>
           <a:p>
             <a:pPr>
@@ -7214,6 +7547,7 @@
                 </a:solidFill>
               </a:defRPr>
             </a:pPr>
+            <a:endParaRPr/>
           </a:p>
           <a:p>
             <a:pPr>
@@ -7262,7 +7596,7 @@
 </file>
 
 <file path=ppt/slides/slide23.xml><?xml version="1.0" encoding="utf-8"?>
-<p:sld xmlns:a="http://schemas.openxmlformats.org/drawingml/2006/main" xmlns:p="http://schemas.openxmlformats.org/presentationml/2006/main" xmlns:r="http://schemas.openxmlformats.org/officeDocument/2006/relationships">
+<p:sld xmlns:a="http://schemas.openxmlformats.org/drawingml/2006/main" xmlns:r="http://schemas.openxmlformats.org/officeDocument/2006/relationships" xmlns:p="http://schemas.openxmlformats.org/presentationml/2006/main">
   <p:cSld>
     <p:bg>
       <p:bgPr>
@@ -7278,7 +7612,14 @@
         <p:cNvGrpSpPr/>
         <p:nvPr/>
       </p:nvGrpSpPr>
-      <p:grpSpPr/>
+      <p:grpSpPr>
+        <a:xfrm>
+          <a:off x="0" y="0"/>
+          <a:ext cx="0" cy="0"/>
+          <a:chOff x="0" y="0"/>
+          <a:chExt cx="0" cy="0"/>
+        </a:xfrm>
+      </p:grpSpPr>
       <p:sp>
         <p:nvSpPr>
           <p:cNvPr id="2" name="TextBox 1"/>
@@ -7356,6 +7697,7 @@
           <a:lstStyle/>
           <a:p>
             <a:pPr algn="ctr"/>
+            <a:endParaRPr/>
           </a:p>
         </p:txBody>
       </p:sp>
@@ -7460,6 +7802,7 @@
                 </a:solidFill>
               </a:defRPr>
             </a:pPr>
+            <a:endParaRPr/>
           </a:p>
           <a:p>
             <a:pPr>
@@ -7547,6 +7890,7 @@
                 </a:solidFill>
               </a:defRPr>
             </a:pPr>
+            <a:endParaRPr/>
           </a:p>
           <a:p>
             <a:pPr>
@@ -7613,7 +7957,7 @@
 </file>
 
 <file path=ppt/slides/slide24.xml><?xml version="1.0" encoding="utf-8"?>
-<p:sld xmlns:a="http://schemas.openxmlformats.org/drawingml/2006/main" xmlns:p="http://schemas.openxmlformats.org/presentationml/2006/main" xmlns:r="http://schemas.openxmlformats.org/officeDocument/2006/relationships">
+<p:sld xmlns:a="http://schemas.openxmlformats.org/drawingml/2006/main" xmlns:r="http://schemas.openxmlformats.org/officeDocument/2006/relationships" xmlns:p="http://schemas.openxmlformats.org/presentationml/2006/main">
   <p:cSld>
     <p:bg>
       <p:bgPr>
@@ -7629,7 +7973,14 @@
         <p:cNvGrpSpPr/>
         <p:nvPr/>
       </p:nvGrpSpPr>
-      <p:grpSpPr/>
+      <p:grpSpPr>
+        <a:xfrm>
+          <a:off x="0" y="0"/>
+          <a:ext cx="0" cy="0"/>
+          <a:chOff x="0" y="0"/>
+          <a:chExt cx="0" cy="0"/>
+        </a:xfrm>
+      </p:grpSpPr>
       <p:sp>
         <p:nvSpPr>
           <p:cNvPr id="2" name="TextBox 1"/>
@@ -7684,9 +8035,27 @@
                 <a:tableStyleId>{5C22544A-7EE6-4342-B048-85BDC9FD1C3A}</a:tableStyleId>
               </a:tblPr>
               <a:tblGrid>
-                <a:gridCol w="3657600"/>
-                <a:gridCol w="3657600"/>
-                <a:gridCol w="3657600"/>
+                <a:gridCol w="3657600">
+                  <a:extLst>
+                    <a:ext uri="{9D8B030D-6E8A-4147-A177-3AD203B41FA5}">
+                      <a16:colId xmlns:a16="http://schemas.microsoft.com/office/drawing/2014/main" val="20000"/>
+                    </a:ext>
+                  </a:extLst>
+                </a:gridCol>
+                <a:gridCol w="3657600">
+                  <a:extLst>
+                    <a:ext uri="{9D8B030D-6E8A-4147-A177-3AD203B41FA5}">
+                      <a16:colId xmlns:a16="http://schemas.microsoft.com/office/drawing/2014/main" val="20001"/>
+                    </a:ext>
+                  </a:extLst>
+                </a:gridCol>
+                <a:gridCol w="3657600">
+                  <a:extLst>
+                    <a:ext uri="{9D8B030D-6E8A-4147-A177-3AD203B41FA5}">
+                      <a16:colId xmlns:a16="http://schemas.microsoft.com/office/drawing/2014/main" val="20002"/>
+                    </a:ext>
+                  </a:extLst>
+                </a:gridCol>
               </a:tblGrid>
               <a:tr h="548640">
                 <a:tc>
@@ -7758,6 +8127,11 @@
                     </a:solidFill>
                   </a:tcPr>
                 </a:tc>
+                <a:extLst>
+                  <a:ext uri="{0D108BD9-81ED-4DB2-BD59-A6C34878D82A}">
+                    <a16:rowId xmlns:a16="http://schemas.microsoft.com/office/drawing/2014/main" val="10000"/>
+                  </a:ext>
+                </a:extLst>
               </a:tr>
               <a:tr h="548640">
                 <a:tc>
@@ -7829,6 +8203,11 @@
                     </a:solidFill>
                   </a:tcPr>
                 </a:tc>
+                <a:extLst>
+                  <a:ext uri="{0D108BD9-81ED-4DB2-BD59-A6C34878D82A}">
+                    <a16:rowId xmlns:a16="http://schemas.microsoft.com/office/drawing/2014/main" val="10001"/>
+                  </a:ext>
+                </a:extLst>
               </a:tr>
               <a:tr h="548640">
                 <a:tc>
@@ -7900,6 +8279,11 @@
                     </a:solidFill>
                   </a:tcPr>
                 </a:tc>
+                <a:extLst>
+                  <a:ext uri="{0D108BD9-81ED-4DB2-BD59-A6C34878D82A}">
+                    <a16:rowId xmlns:a16="http://schemas.microsoft.com/office/drawing/2014/main" val="10002"/>
+                  </a:ext>
+                </a:extLst>
               </a:tr>
               <a:tr h="548640">
                 <a:tc>
@@ -7971,6 +8355,11 @@
                     </a:solidFill>
                   </a:tcPr>
                 </a:tc>
+                <a:extLst>
+                  <a:ext uri="{0D108BD9-81ED-4DB2-BD59-A6C34878D82A}">
+                    <a16:rowId xmlns:a16="http://schemas.microsoft.com/office/drawing/2014/main" val="10003"/>
+                  </a:ext>
+                </a:extLst>
               </a:tr>
               <a:tr h="548640">
                 <a:tc>
@@ -8042,6 +8431,11 @@
                     </a:solidFill>
                   </a:tcPr>
                 </a:tc>
+                <a:extLst>
+                  <a:ext uri="{0D108BD9-81ED-4DB2-BD59-A6C34878D82A}">
+                    <a16:rowId xmlns:a16="http://schemas.microsoft.com/office/drawing/2014/main" val="10004"/>
+                  </a:ext>
+                </a:extLst>
               </a:tr>
             </a:tbl>
           </a:graphicData>
@@ -8056,7 +8450,7 @@
 </file>
 
 <file path=ppt/slides/slide25.xml><?xml version="1.0" encoding="utf-8"?>
-<p:sld xmlns:a="http://schemas.openxmlformats.org/drawingml/2006/main" xmlns:p="http://schemas.openxmlformats.org/presentationml/2006/main" xmlns:r="http://schemas.openxmlformats.org/officeDocument/2006/relationships">
+<p:sld xmlns:a="http://schemas.openxmlformats.org/drawingml/2006/main" xmlns:r="http://schemas.openxmlformats.org/officeDocument/2006/relationships" xmlns:p="http://schemas.openxmlformats.org/presentationml/2006/main">
   <p:cSld>
     <p:bg>
       <p:bgPr>
@@ -8072,7 +8466,14 @@
         <p:cNvGrpSpPr/>
         <p:nvPr/>
       </p:nvGrpSpPr>
-      <p:grpSpPr/>
+      <p:grpSpPr>
+        <a:xfrm>
+          <a:off x="0" y="0"/>
+          <a:ext cx="0" cy="0"/>
+          <a:chOff x="0" y="0"/>
+          <a:chExt cx="0" cy="0"/>
+        </a:xfrm>
+      </p:grpSpPr>
       <p:sp>
         <p:nvSpPr>
           <p:cNvPr id="2" name="Oval 1"/>
@@ -8109,7 +8510,7 @@
           </a:fontRef>
         </p:style>
         <p:txBody>
-          <a:bodyPr rtlCol="0" anchor="ctr" wrap="square"/>
+          <a:bodyPr wrap="square" rtlCol="0" anchor="ctr"/>
           <a:lstStyle/>
           <a:p>
             <a:pPr algn="ctr">
@@ -8169,7 +8570,7 @@
 </file>
 
 <file path=ppt/slides/slide26.xml><?xml version="1.0" encoding="utf-8"?>
-<p:sld xmlns:a="http://schemas.openxmlformats.org/drawingml/2006/main" xmlns:p="http://schemas.openxmlformats.org/presentationml/2006/main" xmlns:r="http://schemas.openxmlformats.org/officeDocument/2006/relationships">
+<p:sld xmlns:a="http://schemas.openxmlformats.org/drawingml/2006/main" xmlns:r="http://schemas.openxmlformats.org/officeDocument/2006/relationships" xmlns:p="http://schemas.openxmlformats.org/presentationml/2006/main">
   <p:cSld>
     <p:bg>
       <p:bgPr>
@@ -8185,7 +8586,14 @@
         <p:cNvGrpSpPr/>
         <p:nvPr/>
       </p:nvGrpSpPr>
-      <p:grpSpPr/>
+      <p:grpSpPr>
+        <a:xfrm>
+          <a:off x="0" y="0"/>
+          <a:ext cx="0" cy="0"/>
+          <a:chOff x="0" y="0"/>
+          <a:chExt cx="0" cy="0"/>
+        </a:xfrm>
+      </p:grpSpPr>
       <p:sp>
         <p:nvSpPr>
           <p:cNvPr id="2" name="TextBox 1"/>
@@ -8263,6 +8671,7 @@
           <a:lstStyle/>
           <a:p>
             <a:pPr algn="ctr"/>
+            <a:endParaRPr/>
           </a:p>
         </p:txBody>
       </p:sp>
@@ -8367,6 +8776,7 @@
                 </a:solidFill>
               </a:defRPr>
             </a:pPr>
+            <a:endParaRPr/>
           </a:p>
           <a:p>
             <a:pPr>
@@ -8436,6 +8846,7 @@
                 </a:solidFill>
               </a:defRPr>
             </a:pPr>
+            <a:endParaRPr/>
           </a:p>
           <a:p>
             <a:pPr>
@@ -8537,7 +8948,7 @@
 </file>
 
 <file path=ppt/slides/slide27.xml><?xml version="1.0" encoding="utf-8"?>
-<p:sld xmlns:a="http://schemas.openxmlformats.org/drawingml/2006/main" xmlns:p="http://schemas.openxmlformats.org/presentationml/2006/main" xmlns:r="http://schemas.openxmlformats.org/officeDocument/2006/relationships">
+<p:sld xmlns:a="http://schemas.openxmlformats.org/drawingml/2006/main" xmlns:r="http://schemas.openxmlformats.org/officeDocument/2006/relationships" xmlns:p="http://schemas.openxmlformats.org/presentationml/2006/main">
   <p:cSld>
     <p:bg>
       <p:bgPr>
@@ -8553,7 +8964,14 @@
         <p:cNvGrpSpPr/>
         <p:nvPr/>
       </p:nvGrpSpPr>
-      <p:grpSpPr/>
+      <p:grpSpPr>
+        <a:xfrm>
+          <a:off x="0" y="0"/>
+          <a:ext cx="0" cy="0"/>
+          <a:chOff x="0" y="0"/>
+          <a:chExt cx="0" cy="0"/>
+        </a:xfrm>
+      </p:grpSpPr>
       <p:sp>
         <p:nvSpPr>
           <p:cNvPr id="2" name="TextBox 1"/>
@@ -8608,11 +9026,41 @@
                 <a:tableStyleId>{5C22544A-7EE6-4342-B048-85BDC9FD1C3A}</a:tableStyleId>
               </a:tblPr>
               <a:tblGrid>
-                <a:gridCol w="2194560"/>
-                <a:gridCol w="2194560"/>
-                <a:gridCol w="2194560"/>
-                <a:gridCol w="2194560"/>
-                <a:gridCol w="2194560"/>
+                <a:gridCol w="2194560">
+                  <a:extLst>
+                    <a:ext uri="{9D8B030D-6E8A-4147-A177-3AD203B41FA5}">
+                      <a16:colId xmlns:a16="http://schemas.microsoft.com/office/drawing/2014/main" val="20000"/>
+                    </a:ext>
+                  </a:extLst>
+                </a:gridCol>
+                <a:gridCol w="2194560">
+                  <a:extLst>
+                    <a:ext uri="{9D8B030D-6E8A-4147-A177-3AD203B41FA5}">
+                      <a16:colId xmlns:a16="http://schemas.microsoft.com/office/drawing/2014/main" val="20001"/>
+                    </a:ext>
+                  </a:extLst>
+                </a:gridCol>
+                <a:gridCol w="2194560">
+                  <a:extLst>
+                    <a:ext uri="{9D8B030D-6E8A-4147-A177-3AD203B41FA5}">
+                      <a16:colId xmlns:a16="http://schemas.microsoft.com/office/drawing/2014/main" val="20002"/>
+                    </a:ext>
+                  </a:extLst>
+                </a:gridCol>
+                <a:gridCol w="2194560">
+                  <a:extLst>
+                    <a:ext uri="{9D8B030D-6E8A-4147-A177-3AD203B41FA5}">
+                      <a16:colId xmlns:a16="http://schemas.microsoft.com/office/drawing/2014/main" val="20003"/>
+                    </a:ext>
+                  </a:extLst>
+                </a:gridCol>
+                <a:gridCol w="2194560">
+                  <a:extLst>
+                    <a:ext uri="{9D8B030D-6E8A-4147-A177-3AD203B41FA5}">
+                      <a16:colId xmlns:a16="http://schemas.microsoft.com/office/drawing/2014/main" val="20004"/>
+                    </a:ext>
+                  </a:extLst>
+                </a:gridCol>
               </a:tblGrid>
               <a:tr h="548640">
                 <a:tc>
@@ -8730,6 +9178,11 @@
                     </a:solidFill>
                   </a:tcPr>
                 </a:tc>
+                <a:extLst>
+                  <a:ext uri="{0D108BD9-81ED-4DB2-BD59-A6C34878D82A}">
+                    <a16:rowId xmlns:a16="http://schemas.microsoft.com/office/drawing/2014/main" val="10000"/>
+                  </a:ext>
+                </a:extLst>
               </a:tr>
               <a:tr h="548640">
                 <a:tc>
@@ -8847,6 +9300,11 @@
                     </a:solidFill>
                   </a:tcPr>
                 </a:tc>
+                <a:extLst>
+                  <a:ext uri="{0D108BD9-81ED-4DB2-BD59-A6C34878D82A}">
+                    <a16:rowId xmlns:a16="http://schemas.microsoft.com/office/drawing/2014/main" val="10001"/>
+                  </a:ext>
+                </a:extLst>
               </a:tr>
               <a:tr h="548640">
                 <a:tc>
@@ -8964,6 +9422,11 @@
                     </a:solidFill>
                   </a:tcPr>
                 </a:tc>
+                <a:extLst>
+                  <a:ext uri="{0D108BD9-81ED-4DB2-BD59-A6C34878D82A}">
+                    <a16:rowId xmlns:a16="http://schemas.microsoft.com/office/drawing/2014/main" val="10002"/>
+                  </a:ext>
+                </a:extLst>
               </a:tr>
               <a:tr h="548640">
                 <a:tc>
@@ -9081,6 +9544,11 @@
                     </a:solidFill>
                   </a:tcPr>
                 </a:tc>
+                <a:extLst>
+                  <a:ext uri="{0D108BD9-81ED-4DB2-BD59-A6C34878D82A}">
+                    <a16:rowId xmlns:a16="http://schemas.microsoft.com/office/drawing/2014/main" val="10003"/>
+                  </a:ext>
+                </a:extLst>
               </a:tr>
               <a:tr h="548640">
                 <a:tc>
@@ -9198,6 +9666,11 @@
                     </a:solidFill>
                   </a:tcPr>
                 </a:tc>
+                <a:extLst>
+                  <a:ext uri="{0D108BD9-81ED-4DB2-BD59-A6C34878D82A}">
+                    <a16:rowId xmlns:a16="http://schemas.microsoft.com/office/drawing/2014/main" val="10004"/>
+                  </a:ext>
+                </a:extLst>
               </a:tr>
             </a:tbl>
           </a:graphicData>
@@ -9212,7 +9685,7 @@
 </file>
 
 <file path=ppt/slides/slide28.xml><?xml version="1.0" encoding="utf-8"?>
-<p:sld xmlns:a="http://schemas.openxmlformats.org/drawingml/2006/main" xmlns:p="http://schemas.openxmlformats.org/presentationml/2006/main" xmlns:r="http://schemas.openxmlformats.org/officeDocument/2006/relationships">
+<p:sld xmlns:a="http://schemas.openxmlformats.org/drawingml/2006/main" xmlns:r="http://schemas.openxmlformats.org/officeDocument/2006/relationships" xmlns:p="http://schemas.openxmlformats.org/presentationml/2006/main">
   <p:cSld>
     <p:bg>
       <p:bgPr>
@@ -9228,7 +9701,14 @@
         <p:cNvGrpSpPr/>
         <p:nvPr/>
       </p:nvGrpSpPr>
-      <p:grpSpPr/>
+      <p:grpSpPr>
+        <a:xfrm>
+          <a:off x="0" y="0"/>
+          <a:ext cx="0" cy="0"/>
+          <a:chOff x="0" y="0"/>
+          <a:chExt cx="0" cy="0"/>
+        </a:xfrm>
+      </p:grpSpPr>
       <p:sp>
         <p:nvSpPr>
           <p:cNvPr id="2" name="TextBox 1"/>
@@ -9306,6 +9786,7 @@
           <a:lstStyle/>
           <a:p>
             <a:pPr algn="ctr"/>
+            <a:endParaRPr/>
           </a:p>
         </p:txBody>
       </p:sp>
@@ -9356,6 +9837,7 @@
                 </a:solidFill>
               </a:defRPr>
             </a:pPr>
+            <a:endParaRPr/>
           </a:p>
           <a:p>
             <a:pPr>
@@ -9461,6 +9943,7 @@
                 </a:solidFill>
               </a:defRPr>
             </a:pPr>
+            <a:endParaRPr/>
           </a:p>
           <a:p>
             <a:pPr>
@@ -9530,6 +10013,7 @@
                 </a:solidFill>
               </a:defRPr>
             </a:pPr>
+            <a:endParaRPr/>
           </a:p>
           <a:p>
             <a:pPr>
@@ -9578,7 +10062,7 @@
 </file>
 
 <file path=ppt/slides/slide29.xml><?xml version="1.0" encoding="utf-8"?>
-<p:sld xmlns:a="http://schemas.openxmlformats.org/drawingml/2006/main" xmlns:p="http://schemas.openxmlformats.org/presentationml/2006/main" xmlns:r="http://schemas.openxmlformats.org/officeDocument/2006/relationships">
+<p:sld xmlns:a="http://schemas.openxmlformats.org/drawingml/2006/main" xmlns:r="http://schemas.openxmlformats.org/officeDocument/2006/relationships" xmlns:p="http://schemas.openxmlformats.org/presentationml/2006/main">
   <p:cSld>
     <p:bg>
       <p:bgPr>
@@ -9594,7 +10078,14 @@
         <p:cNvGrpSpPr/>
         <p:nvPr/>
       </p:nvGrpSpPr>
-      <p:grpSpPr/>
+      <p:grpSpPr>
+        <a:xfrm>
+          <a:off x="0" y="0"/>
+          <a:ext cx="0" cy="0"/>
+          <a:chOff x="0" y="0"/>
+          <a:chExt cx="0" cy="0"/>
+        </a:xfrm>
+      </p:grpSpPr>
       <p:sp>
         <p:nvSpPr>
           <p:cNvPr id="2" name="TextBox 1"/>
@@ -9672,6 +10163,7 @@
           <a:lstStyle/>
           <a:p>
             <a:pPr algn="ctr"/>
+            <a:endParaRPr/>
           </a:p>
         </p:txBody>
       </p:sp>
@@ -9847,6 +10339,7 @@
                 </a:solidFill>
               </a:defRPr>
             </a:pPr>
+            <a:endParaRPr/>
           </a:p>
           <a:p>
             <a:pPr>
@@ -9916,6 +10409,7 @@
                 </a:solidFill>
               </a:defRPr>
             </a:pPr>
+            <a:endParaRPr/>
           </a:p>
           <a:p>
             <a:pPr>
@@ -9997,6 +10491,7 @@
           <a:lstStyle/>
           <a:p>
             <a:pPr algn="ctr"/>
+            <a:endParaRPr/>
           </a:p>
         </p:txBody>
       </p:sp>
@@ -10118,6 +10613,7 @@
                 </a:solidFill>
               </a:defRPr>
             </a:pPr>
+            <a:endParaRPr/>
           </a:p>
           <a:p>
             <a:pPr>
@@ -10151,6 +10647,7 @@
                 </a:solidFill>
               </a:defRPr>
             </a:pPr>
+            <a:endParaRPr/>
           </a:p>
           <a:p>
             <a:pPr>
@@ -10220,6 +10717,7 @@
                 </a:solidFill>
               </a:defRPr>
             </a:pPr>
+            <a:endParaRPr/>
           </a:p>
           <a:p>
             <a:pPr>
@@ -10301,6 +10799,7 @@
           <a:lstStyle/>
           <a:p>
             <a:pPr algn="ctr"/>
+            <a:endParaRPr/>
           </a:p>
         </p:txBody>
       </p:sp>
@@ -10404,6 +10903,7 @@
                 </a:solidFill>
               </a:defRPr>
             </a:pPr>
+            <a:endParaRPr/>
           </a:p>
           <a:p>
             <a:pPr>
@@ -10491,6 +10991,7 @@
                 </a:solidFill>
               </a:defRPr>
             </a:pPr>
+            <a:endParaRPr/>
           </a:p>
           <a:p>
             <a:pPr>
@@ -10542,6 +11043,7 @@
                 </a:solidFill>
               </a:defRPr>
             </a:pPr>
+            <a:endParaRPr/>
           </a:p>
           <a:p>
             <a:pPr>
@@ -10625,7 +11127,7 @@
 </file>
 
 <file path=ppt/slides/slide3.xml><?xml version="1.0" encoding="utf-8"?>
-<p:sld xmlns:a="http://schemas.openxmlformats.org/drawingml/2006/main" xmlns:p="http://schemas.openxmlformats.org/presentationml/2006/main" xmlns:r="http://schemas.openxmlformats.org/officeDocument/2006/relationships">
+<p:sld xmlns:a="http://schemas.openxmlformats.org/drawingml/2006/main" xmlns:r="http://schemas.openxmlformats.org/officeDocument/2006/relationships" xmlns:p="http://schemas.openxmlformats.org/presentationml/2006/main">
   <p:cSld>
     <p:bg>
       <p:bgPr>
@@ -10641,7 +11143,14 @@
         <p:cNvGrpSpPr/>
         <p:nvPr/>
       </p:nvGrpSpPr>
-      <p:grpSpPr/>
+      <p:grpSpPr>
+        <a:xfrm>
+          <a:off x="0" y="0"/>
+          <a:ext cx="0" cy="0"/>
+          <a:chOff x="0" y="0"/>
+          <a:chExt cx="0" cy="0"/>
+        </a:xfrm>
+      </p:grpSpPr>
       <p:sp>
         <p:nvSpPr>
           <p:cNvPr id="2" name="TextBox 1"/>
@@ -10696,9 +11205,27 @@
                 <a:tableStyleId>{5C22544A-7EE6-4342-B048-85BDC9FD1C3A}</a:tableStyleId>
               </a:tblPr>
               <a:tblGrid>
-                <a:gridCol w="3657600"/>
-                <a:gridCol w="3657600"/>
-                <a:gridCol w="3657600"/>
+                <a:gridCol w="3657600">
+                  <a:extLst>
+                    <a:ext uri="{9D8B030D-6E8A-4147-A177-3AD203B41FA5}">
+                      <a16:colId xmlns:a16="http://schemas.microsoft.com/office/drawing/2014/main" val="20000"/>
+                    </a:ext>
+                  </a:extLst>
+                </a:gridCol>
+                <a:gridCol w="3657600">
+                  <a:extLst>
+                    <a:ext uri="{9D8B030D-6E8A-4147-A177-3AD203B41FA5}">
+                      <a16:colId xmlns:a16="http://schemas.microsoft.com/office/drawing/2014/main" val="20001"/>
+                    </a:ext>
+                  </a:extLst>
+                </a:gridCol>
+                <a:gridCol w="3657600">
+                  <a:extLst>
+                    <a:ext uri="{9D8B030D-6E8A-4147-A177-3AD203B41FA5}">
+                      <a16:colId xmlns:a16="http://schemas.microsoft.com/office/drawing/2014/main" val="20002"/>
+                    </a:ext>
+                  </a:extLst>
+                </a:gridCol>
               </a:tblGrid>
               <a:tr h="548640">
                 <a:tc>
@@ -10770,6 +11297,11 @@
                     </a:solidFill>
                   </a:tcPr>
                 </a:tc>
+                <a:extLst>
+                  <a:ext uri="{0D108BD9-81ED-4DB2-BD59-A6C34878D82A}">
+                    <a16:rowId xmlns:a16="http://schemas.microsoft.com/office/drawing/2014/main" val="10000"/>
+                  </a:ext>
+                </a:extLst>
               </a:tr>
               <a:tr h="548640">
                 <a:tc>
@@ -10841,6 +11373,11 @@
                     </a:solidFill>
                   </a:tcPr>
                 </a:tc>
+                <a:extLst>
+                  <a:ext uri="{0D108BD9-81ED-4DB2-BD59-A6C34878D82A}">
+                    <a16:rowId xmlns:a16="http://schemas.microsoft.com/office/drawing/2014/main" val="10001"/>
+                  </a:ext>
+                </a:extLst>
               </a:tr>
               <a:tr h="548640">
                 <a:tc>
@@ -10912,6 +11449,11 @@
                     </a:solidFill>
                   </a:tcPr>
                 </a:tc>
+                <a:extLst>
+                  <a:ext uri="{0D108BD9-81ED-4DB2-BD59-A6C34878D82A}">
+                    <a16:rowId xmlns:a16="http://schemas.microsoft.com/office/drawing/2014/main" val="10002"/>
+                  </a:ext>
+                </a:extLst>
               </a:tr>
               <a:tr h="548640">
                 <a:tc>
@@ -10983,6 +11525,11 @@
                     </a:solidFill>
                   </a:tcPr>
                 </a:tc>
+                <a:extLst>
+                  <a:ext uri="{0D108BD9-81ED-4DB2-BD59-A6C34878D82A}">
+                    <a16:rowId xmlns:a16="http://schemas.microsoft.com/office/drawing/2014/main" val="10003"/>
+                  </a:ext>
+                </a:extLst>
               </a:tr>
               <a:tr h="548640">
                 <a:tc>
@@ -11054,6 +11601,11 @@
                     </a:solidFill>
                   </a:tcPr>
                 </a:tc>
+                <a:extLst>
+                  <a:ext uri="{0D108BD9-81ED-4DB2-BD59-A6C34878D82A}">
+                    <a16:rowId xmlns:a16="http://schemas.microsoft.com/office/drawing/2014/main" val="10004"/>
+                  </a:ext>
+                </a:extLst>
               </a:tr>
             </a:tbl>
           </a:graphicData>
@@ -11068,7 +11620,7 @@
 </file>
 
 <file path=ppt/slides/slide30.xml><?xml version="1.0" encoding="utf-8"?>
-<p:sld xmlns:a="http://schemas.openxmlformats.org/drawingml/2006/main" xmlns:p="http://schemas.openxmlformats.org/presentationml/2006/main" xmlns:r="http://schemas.openxmlformats.org/officeDocument/2006/relationships">
+<p:sld xmlns:a="http://schemas.openxmlformats.org/drawingml/2006/main" xmlns:r="http://schemas.openxmlformats.org/officeDocument/2006/relationships" xmlns:p="http://schemas.openxmlformats.org/presentationml/2006/main">
   <p:cSld>
     <p:bg>
       <p:bgPr>
@@ -11084,7 +11636,14 @@
         <p:cNvGrpSpPr/>
         <p:nvPr/>
       </p:nvGrpSpPr>
-      <p:grpSpPr/>
+      <p:grpSpPr>
+        <a:xfrm>
+          <a:off x="0" y="0"/>
+          <a:ext cx="0" cy="0"/>
+          <a:chOff x="0" y="0"/>
+          <a:chExt cx="0" cy="0"/>
+        </a:xfrm>
+      </p:grpSpPr>
       <p:sp>
         <p:nvSpPr>
           <p:cNvPr id="2" name="Oval 1"/>
@@ -11121,7 +11680,7 @@
           </a:fontRef>
         </p:style>
         <p:txBody>
-          <a:bodyPr rtlCol="0" anchor="ctr" wrap="square"/>
+          <a:bodyPr wrap="square" rtlCol="0" anchor="ctr"/>
           <a:lstStyle/>
           <a:p>
             <a:pPr algn="ctr">
@@ -11181,7 +11740,7 @@
 </file>
 
 <file path=ppt/slides/slide31.xml><?xml version="1.0" encoding="utf-8"?>
-<p:sld xmlns:a="http://schemas.openxmlformats.org/drawingml/2006/main" xmlns:p="http://schemas.openxmlformats.org/presentationml/2006/main" xmlns:r="http://schemas.openxmlformats.org/officeDocument/2006/relationships">
+<p:sld xmlns:a="http://schemas.openxmlformats.org/drawingml/2006/main" xmlns:r="http://schemas.openxmlformats.org/officeDocument/2006/relationships" xmlns:p="http://schemas.openxmlformats.org/presentationml/2006/main">
   <p:cSld>
     <p:bg>
       <p:bgPr>
@@ -11197,7 +11756,14 @@
         <p:cNvGrpSpPr/>
         <p:nvPr/>
       </p:nvGrpSpPr>
-      <p:grpSpPr/>
+      <p:grpSpPr>
+        <a:xfrm>
+          <a:off x="0" y="0"/>
+          <a:ext cx="0" cy="0"/>
+          <a:chOff x="0" y="0"/>
+          <a:chExt cx="0" cy="0"/>
+        </a:xfrm>
+      </p:grpSpPr>
       <p:sp>
         <p:nvSpPr>
           <p:cNvPr id="2" name="TextBox 1"/>
@@ -11252,8 +11818,20 @@
                 <a:tableStyleId>{5C22544A-7EE6-4342-B048-85BDC9FD1C3A}</a:tableStyleId>
               </a:tblPr>
               <a:tblGrid>
-                <a:gridCol w="5486400"/>
-                <a:gridCol w="5486400"/>
+                <a:gridCol w="5486400">
+                  <a:extLst>
+                    <a:ext uri="{9D8B030D-6E8A-4147-A177-3AD203B41FA5}">
+                      <a16:colId xmlns:a16="http://schemas.microsoft.com/office/drawing/2014/main" val="20000"/>
+                    </a:ext>
+                  </a:extLst>
+                </a:gridCol>
+                <a:gridCol w="5486400">
+                  <a:extLst>
+                    <a:ext uri="{9D8B030D-6E8A-4147-A177-3AD203B41FA5}">
+                      <a16:colId xmlns:a16="http://schemas.microsoft.com/office/drawing/2014/main" val="20001"/>
+                    </a:ext>
+                  </a:extLst>
+                </a:gridCol>
               </a:tblGrid>
               <a:tr h="508000">
                 <a:tc>
@@ -11302,6 +11880,11 @@
                     </a:solidFill>
                   </a:tcPr>
                 </a:tc>
+                <a:extLst>
+                  <a:ext uri="{0D108BD9-81ED-4DB2-BD59-A6C34878D82A}">
+                    <a16:rowId xmlns:a16="http://schemas.microsoft.com/office/drawing/2014/main" val="10000"/>
+                  </a:ext>
+                </a:extLst>
               </a:tr>
               <a:tr h="508000">
                 <a:tc>
@@ -11350,6 +11933,11 @@
                     </a:solidFill>
                   </a:tcPr>
                 </a:tc>
+                <a:extLst>
+                  <a:ext uri="{0D108BD9-81ED-4DB2-BD59-A6C34878D82A}">
+                    <a16:rowId xmlns:a16="http://schemas.microsoft.com/office/drawing/2014/main" val="10001"/>
+                  </a:ext>
+                </a:extLst>
               </a:tr>
               <a:tr h="508000">
                 <a:tc>
@@ -11398,6 +11986,11 @@
                     </a:solidFill>
                   </a:tcPr>
                 </a:tc>
+                <a:extLst>
+                  <a:ext uri="{0D108BD9-81ED-4DB2-BD59-A6C34878D82A}">
+                    <a16:rowId xmlns:a16="http://schemas.microsoft.com/office/drawing/2014/main" val="10002"/>
+                  </a:ext>
+                </a:extLst>
               </a:tr>
               <a:tr h="508000">
                 <a:tc>
@@ -11446,6 +12039,11 @@
                     </a:solidFill>
                   </a:tcPr>
                 </a:tc>
+                <a:extLst>
+                  <a:ext uri="{0D108BD9-81ED-4DB2-BD59-A6C34878D82A}">
+                    <a16:rowId xmlns:a16="http://schemas.microsoft.com/office/drawing/2014/main" val="10003"/>
+                  </a:ext>
+                </a:extLst>
               </a:tr>
               <a:tr h="508000">
                 <a:tc>
@@ -11494,6 +12092,11 @@
                     </a:solidFill>
                   </a:tcPr>
                 </a:tc>
+                <a:extLst>
+                  <a:ext uri="{0D108BD9-81ED-4DB2-BD59-A6C34878D82A}">
+                    <a16:rowId xmlns:a16="http://schemas.microsoft.com/office/drawing/2014/main" val="10004"/>
+                  </a:ext>
+                </a:extLst>
               </a:tr>
               <a:tr h="508000">
                 <a:tc>
@@ -11542,6 +12145,11 @@
                     </a:solidFill>
                   </a:tcPr>
                 </a:tc>
+                <a:extLst>
+                  <a:ext uri="{0D108BD9-81ED-4DB2-BD59-A6C34878D82A}">
+                    <a16:rowId xmlns:a16="http://schemas.microsoft.com/office/drawing/2014/main" val="10005"/>
+                  </a:ext>
+                </a:extLst>
               </a:tr>
               <a:tr h="508000">
                 <a:tc>
@@ -11590,6 +12198,11 @@
                     </a:solidFill>
                   </a:tcPr>
                 </a:tc>
+                <a:extLst>
+                  <a:ext uri="{0D108BD9-81ED-4DB2-BD59-A6C34878D82A}">
+                    <a16:rowId xmlns:a16="http://schemas.microsoft.com/office/drawing/2014/main" val="10006"/>
+                  </a:ext>
+                </a:extLst>
               </a:tr>
               <a:tr h="508000">
                 <a:tc>
@@ -11638,6 +12251,11 @@
                     </a:solidFill>
                   </a:tcPr>
                 </a:tc>
+                <a:extLst>
+                  <a:ext uri="{0D108BD9-81ED-4DB2-BD59-A6C34878D82A}">
+                    <a16:rowId xmlns:a16="http://schemas.microsoft.com/office/drawing/2014/main" val="10007"/>
+                  </a:ext>
+                </a:extLst>
               </a:tr>
               <a:tr h="508000">
                 <a:tc>
@@ -11686,6 +12304,11 @@
                     </a:solidFill>
                   </a:tcPr>
                 </a:tc>
+                <a:extLst>
+                  <a:ext uri="{0D108BD9-81ED-4DB2-BD59-A6C34878D82A}">
+                    <a16:rowId xmlns:a16="http://schemas.microsoft.com/office/drawing/2014/main" val="10008"/>
+                  </a:ext>
+                </a:extLst>
               </a:tr>
             </a:tbl>
           </a:graphicData>
@@ -11700,7 +12323,7 @@
 </file>
 
 <file path=ppt/slides/slide32.xml><?xml version="1.0" encoding="utf-8"?>
-<p:sld xmlns:a="http://schemas.openxmlformats.org/drawingml/2006/main" xmlns:p="http://schemas.openxmlformats.org/presentationml/2006/main" xmlns:r="http://schemas.openxmlformats.org/officeDocument/2006/relationships">
+<p:sld xmlns:a="http://schemas.openxmlformats.org/drawingml/2006/main" xmlns:r="http://schemas.openxmlformats.org/officeDocument/2006/relationships" xmlns:p="http://schemas.openxmlformats.org/presentationml/2006/main">
   <p:cSld>
     <p:bg>
       <p:bgPr>
@@ -11716,7 +12339,14 @@
         <p:cNvGrpSpPr/>
         <p:nvPr/>
       </p:nvGrpSpPr>
-      <p:grpSpPr/>
+      <p:grpSpPr>
+        <a:xfrm>
+          <a:off x="0" y="0"/>
+          <a:ext cx="0" cy="0"/>
+          <a:chOff x="0" y="0"/>
+          <a:chExt cx="0" cy="0"/>
+        </a:xfrm>
+      </p:grpSpPr>
       <p:sp>
         <p:nvSpPr>
           <p:cNvPr id="2" name="TextBox 1"/>
@@ -11771,8 +12401,20 @@
                 <a:tableStyleId>{5C22544A-7EE6-4342-B048-85BDC9FD1C3A}</a:tableStyleId>
               </a:tblPr>
               <a:tblGrid>
-                <a:gridCol w="5486400"/>
-                <a:gridCol w="5486400"/>
+                <a:gridCol w="5486400">
+                  <a:extLst>
+                    <a:ext uri="{9D8B030D-6E8A-4147-A177-3AD203B41FA5}">
+                      <a16:colId xmlns:a16="http://schemas.microsoft.com/office/drawing/2014/main" val="20000"/>
+                    </a:ext>
+                  </a:extLst>
+                </a:gridCol>
+                <a:gridCol w="5486400">
+                  <a:extLst>
+                    <a:ext uri="{9D8B030D-6E8A-4147-A177-3AD203B41FA5}">
+                      <a16:colId xmlns:a16="http://schemas.microsoft.com/office/drawing/2014/main" val="20001"/>
+                    </a:ext>
+                  </a:extLst>
+                </a:gridCol>
               </a:tblGrid>
               <a:tr h="502920">
                 <a:tc>
@@ -11821,6 +12463,11 @@
                     </a:solidFill>
                   </a:tcPr>
                 </a:tc>
+                <a:extLst>
+                  <a:ext uri="{0D108BD9-81ED-4DB2-BD59-A6C34878D82A}">
+                    <a16:rowId xmlns:a16="http://schemas.microsoft.com/office/drawing/2014/main" val="10000"/>
+                  </a:ext>
+                </a:extLst>
               </a:tr>
               <a:tr h="502920">
                 <a:tc>
@@ -11869,6 +12516,11 @@
                     </a:solidFill>
                   </a:tcPr>
                 </a:tc>
+                <a:extLst>
+                  <a:ext uri="{0D108BD9-81ED-4DB2-BD59-A6C34878D82A}">
+                    <a16:rowId xmlns:a16="http://schemas.microsoft.com/office/drawing/2014/main" val="10001"/>
+                  </a:ext>
+                </a:extLst>
               </a:tr>
               <a:tr h="502920">
                 <a:tc>
@@ -11917,6 +12569,11 @@
                     </a:solidFill>
                   </a:tcPr>
                 </a:tc>
+                <a:extLst>
+                  <a:ext uri="{0D108BD9-81ED-4DB2-BD59-A6C34878D82A}">
+                    <a16:rowId xmlns:a16="http://schemas.microsoft.com/office/drawing/2014/main" val="10002"/>
+                  </a:ext>
+                </a:extLst>
               </a:tr>
               <a:tr h="502920">
                 <a:tc>
@@ -11965,6 +12622,11 @@
                     </a:solidFill>
                   </a:tcPr>
                 </a:tc>
+                <a:extLst>
+                  <a:ext uri="{0D108BD9-81ED-4DB2-BD59-A6C34878D82A}">
+                    <a16:rowId xmlns:a16="http://schemas.microsoft.com/office/drawing/2014/main" val="10003"/>
+                  </a:ext>
+                </a:extLst>
               </a:tr>
               <a:tr h="502920">
                 <a:tc>
@@ -12013,6 +12675,11 @@
                     </a:solidFill>
                   </a:tcPr>
                 </a:tc>
+                <a:extLst>
+                  <a:ext uri="{0D108BD9-81ED-4DB2-BD59-A6C34878D82A}">
+                    <a16:rowId xmlns:a16="http://schemas.microsoft.com/office/drawing/2014/main" val="10004"/>
+                  </a:ext>
+                </a:extLst>
               </a:tr>
               <a:tr h="502920">
                 <a:tc>
@@ -12061,6 +12728,11 @@
                     </a:solidFill>
                   </a:tcPr>
                 </a:tc>
+                <a:extLst>
+                  <a:ext uri="{0D108BD9-81ED-4DB2-BD59-A6C34878D82A}">
+                    <a16:rowId xmlns:a16="http://schemas.microsoft.com/office/drawing/2014/main" val="10005"/>
+                  </a:ext>
+                </a:extLst>
               </a:tr>
               <a:tr h="502920">
                 <a:tc>
@@ -12109,6 +12781,11 @@
                     </a:solidFill>
                   </a:tcPr>
                 </a:tc>
+                <a:extLst>
+                  <a:ext uri="{0D108BD9-81ED-4DB2-BD59-A6C34878D82A}">
+                    <a16:rowId xmlns:a16="http://schemas.microsoft.com/office/drawing/2014/main" val="10006"/>
+                  </a:ext>
+                </a:extLst>
               </a:tr>
               <a:tr h="502920">
                 <a:tc>
@@ -12157,6 +12834,11 @@
                     </a:solidFill>
                   </a:tcPr>
                 </a:tc>
+                <a:extLst>
+                  <a:ext uri="{0D108BD9-81ED-4DB2-BD59-A6C34878D82A}">
+                    <a16:rowId xmlns:a16="http://schemas.microsoft.com/office/drawing/2014/main" val="10007"/>
+                  </a:ext>
+                </a:extLst>
               </a:tr>
               <a:tr h="502920">
                 <a:tc>
@@ -12205,6 +12887,11 @@
                     </a:solidFill>
                   </a:tcPr>
                 </a:tc>
+                <a:extLst>
+                  <a:ext uri="{0D108BD9-81ED-4DB2-BD59-A6C34878D82A}">
+                    <a16:rowId xmlns:a16="http://schemas.microsoft.com/office/drawing/2014/main" val="10008"/>
+                  </a:ext>
+                </a:extLst>
               </a:tr>
               <a:tr h="502920">
                 <a:tc>
@@ -12253,6 +12940,11 @@
                     </a:solidFill>
                   </a:tcPr>
                 </a:tc>
+                <a:extLst>
+                  <a:ext uri="{0D108BD9-81ED-4DB2-BD59-A6C34878D82A}">
+                    <a16:rowId xmlns:a16="http://schemas.microsoft.com/office/drawing/2014/main" val="10009"/>
+                  </a:ext>
+                </a:extLst>
               </a:tr>
             </a:tbl>
           </a:graphicData>
@@ -12267,7 +12959,7 @@
 </file>
 
 <file path=ppt/slides/slide33.xml><?xml version="1.0" encoding="utf-8"?>
-<p:sld xmlns:a="http://schemas.openxmlformats.org/drawingml/2006/main" xmlns:p="http://schemas.openxmlformats.org/presentationml/2006/main" xmlns:r="http://schemas.openxmlformats.org/officeDocument/2006/relationships">
+<p:sld xmlns:a="http://schemas.openxmlformats.org/drawingml/2006/main" xmlns:r="http://schemas.openxmlformats.org/officeDocument/2006/relationships" xmlns:p="http://schemas.openxmlformats.org/presentationml/2006/main">
   <p:cSld>
     <p:bg>
       <p:bgPr>
@@ -12283,7 +12975,14 @@
         <p:cNvGrpSpPr/>
         <p:nvPr/>
       </p:nvGrpSpPr>
-      <p:grpSpPr/>
+      <p:grpSpPr>
+        <a:xfrm>
+          <a:off x="0" y="0"/>
+          <a:ext cx="0" cy="0"/>
+          <a:chOff x="0" y="0"/>
+          <a:chExt cx="0" cy="0"/>
+        </a:xfrm>
+      </p:grpSpPr>
       <p:sp>
         <p:nvSpPr>
           <p:cNvPr id="2" name="Oval 1"/>
@@ -12320,7 +13019,7 @@
           </a:fontRef>
         </p:style>
         <p:txBody>
-          <a:bodyPr rtlCol="0" anchor="ctr" wrap="square"/>
+          <a:bodyPr wrap="square" rtlCol="0" anchor="ctr"/>
           <a:lstStyle/>
           <a:p>
             <a:pPr algn="ctr">
@@ -12380,7 +13079,7 @@
 </file>
 
 <file path=ppt/slides/slide34.xml><?xml version="1.0" encoding="utf-8"?>
-<p:sld xmlns:a="http://schemas.openxmlformats.org/drawingml/2006/main" xmlns:p="http://schemas.openxmlformats.org/presentationml/2006/main" xmlns:r="http://schemas.openxmlformats.org/officeDocument/2006/relationships">
+<p:sld xmlns:a="http://schemas.openxmlformats.org/drawingml/2006/main" xmlns:r="http://schemas.openxmlformats.org/officeDocument/2006/relationships" xmlns:p="http://schemas.openxmlformats.org/presentationml/2006/main">
   <p:cSld>
     <p:bg>
       <p:bgPr>
@@ -12396,7 +13095,14 @@
         <p:cNvGrpSpPr/>
         <p:nvPr/>
       </p:nvGrpSpPr>
-      <p:grpSpPr/>
+      <p:grpSpPr>
+        <a:xfrm>
+          <a:off x="0" y="0"/>
+          <a:ext cx="0" cy="0"/>
+          <a:chOff x="0" y="0"/>
+          <a:chExt cx="0" cy="0"/>
+        </a:xfrm>
+      </p:grpSpPr>
       <p:sp>
         <p:nvSpPr>
           <p:cNvPr id="2" name="TextBox 1"/>
@@ -12451,8 +13157,20 @@
                 <a:tableStyleId>{5C22544A-7EE6-4342-B048-85BDC9FD1C3A}</a:tableStyleId>
               </a:tblPr>
               <a:tblGrid>
-                <a:gridCol w="5486400"/>
-                <a:gridCol w="5486400"/>
+                <a:gridCol w="5486400">
+                  <a:extLst>
+                    <a:ext uri="{9D8B030D-6E8A-4147-A177-3AD203B41FA5}">
+                      <a16:colId xmlns:a16="http://schemas.microsoft.com/office/drawing/2014/main" val="20000"/>
+                    </a:ext>
+                  </a:extLst>
+                </a:gridCol>
+                <a:gridCol w="5486400">
+                  <a:extLst>
+                    <a:ext uri="{9D8B030D-6E8A-4147-A177-3AD203B41FA5}">
+                      <a16:colId xmlns:a16="http://schemas.microsoft.com/office/drawing/2014/main" val="20001"/>
+                    </a:ext>
+                  </a:extLst>
+                </a:gridCol>
               </a:tblGrid>
               <a:tr h="522514">
                 <a:tc>
@@ -12501,6 +13219,11 @@
                     </a:solidFill>
                   </a:tcPr>
                 </a:tc>
+                <a:extLst>
+                  <a:ext uri="{0D108BD9-81ED-4DB2-BD59-A6C34878D82A}">
+                    <a16:rowId xmlns:a16="http://schemas.microsoft.com/office/drawing/2014/main" val="10000"/>
+                  </a:ext>
+                </a:extLst>
               </a:tr>
               <a:tr h="522514">
                 <a:tc>
@@ -12549,6 +13272,11 @@
                     </a:solidFill>
                   </a:tcPr>
                 </a:tc>
+                <a:extLst>
+                  <a:ext uri="{0D108BD9-81ED-4DB2-BD59-A6C34878D82A}">
+                    <a16:rowId xmlns:a16="http://schemas.microsoft.com/office/drawing/2014/main" val="10001"/>
+                  </a:ext>
+                </a:extLst>
               </a:tr>
               <a:tr h="522514">
                 <a:tc>
@@ -12597,6 +13325,11 @@
                     </a:solidFill>
                   </a:tcPr>
                 </a:tc>
+                <a:extLst>
+                  <a:ext uri="{0D108BD9-81ED-4DB2-BD59-A6C34878D82A}">
+                    <a16:rowId xmlns:a16="http://schemas.microsoft.com/office/drawing/2014/main" val="10002"/>
+                  </a:ext>
+                </a:extLst>
               </a:tr>
               <a:tr h="522514">
                 <a:tc>
@@ -12645,6 +13378,11 @@
                     </a:solidFill>
                   </a:tcPr>
                 </a:tc>
+                <a:extLst>
+                  <a:ext uri="{0D108BD9-81ED-4DB2-BD59-A6C34878D82A}">
+                    <a16:rowId xmlns:a16="http://schemas.microsoft.com/office/drawing/2014/main" val="10003"/>
+                  </a:ext>
+                </a:extLst>
               </a:tr>
               <a:tr h="522514">
                 <a:tc>
@@ -12693,6 +13431,11 @@
                     </a:solidFill>
                   </a:tcPr>
                 </a:tc>
+                <a:extLst>
+                  <a:ext uri="{0D108BD9-81ED-4DB2-BD59-A6C34878D82A}">
+                    <a16:rowId xmlns:a16="http://schemas.microsoft.com/office/drawing/2014/main" val="10004"/>
+                  </a:ext>
+                </a:extLst>
               </a:tr>
               <a:tr h="522514">
                 <a:tc>
@@ -12741,6 +13484,11 @@
                     </a:solidFill>
                   </a:tcPr>
                 </a:tc>
+                <a:extLst>
+                  <a:ext uri="{0D108BD9-81ED-4DB2-BD59-A6C34878D82A}">
+                    <a16:rowId xmlns:a16="http://schemas.microsoft.com/office/drawing/2014/main" val="10005"/>
+                  </a:ext>
+                </a:extLst>
               </a:tr>
               <a:tr h="522516">
                 <a:tc>
@@ -12789,6 +13537,11 @@
                     </a:solidFill>
                   </a:tcPr>
                 </a:tc>
+                <a:extLst>
+                  <a:ext uri="{0D108BD9-81ED-4DB2-BD59-A6C34878D82A}">
+                    <a16:rowId xmlns:a16="http://schemas.microsoft.com/office/drawing/2014/main" val="10006"/>
+                  </a:ext>
+                </a:extLst>
               </a:tr>
             </a:tbl>
           </a:graphicData>
@@ -12803,7 +13556,7 @@
 </file>
 
 <file path=ppt/slides/slide35.xml><?xml version="1.0" encoding="utf-8"?>
-<p:sld xmlns:a="http://schemas.openxmlformats.org/drawingml/2006/main" xmlns:p="http://schemas.openxmlformats.org/presentationml/2006/main" xmlns:r="http://schemas.openxmlformats.org/officeDocument/2006/relationships">
+<p:sld xmlns:a="http://schemas.openxmlformats.org/drawingml/2006/main" xmlns:r="http://schemas.openxmlformats.org/officeDocument/2006/relationships" xmlns:p="http://schemas.openxmlformats.org/presentationml/2006/main">
   <p:cSld>
     <p:bg>
       <p:bgPr>
@@ -12819,7 +13572,14 @@
         <p:cNvGrpSpPr/>
         <p:nvPr/>
       </p:nvGrpSpPr>
-      <p:grpSpPr/>
+      <p:grpSpPr>
+        <a:xfrm>
+          <a:off x="0" y="0"/>
+          <a:ext cx="0" cy="0"/>
+          <a:chOff x="0" y="0"/>
+          <a:chExt cx="0" cy="0"/>
+        </a:xfrm>
+      </p:grpSpPr>
       <p:sp>
         <p:nvSpPr>
           <p:cNvPr id="2" name="TextBox 1"/>
@@ -12897,6 +13657,7 @@
           <a:lstStyle/>
           <a:p>
             <a:pPr algn="ctr"/>
+            <a:endParaRPr/>
           </a:p>
         </p:txBody>
       </p:sp>
@@ -13000,6 +13761,7 @@
                 </a:solidFill>
               </a:defRPr>
             </a:pPr>
+            <a:endParaRPr/>
           </a:p>
           <a:p>
             <a:pPr>
@@ -13087,6 +13849,7 @@
                 </a:solidFill>
               </a:defRPr>
             </a:pPr>
+            <a:endParaRPr/>
           </a:p>
           <a:p>
             <a:pPr>
@@ -13138,6 +13901,7 @@
                 </a:solidFill>
               </a:defRPr>
             </a:pPr>
+            <a:endParaRPr/>
           </a:p>
           <a:p>
             <a:pPr>
@@ -13219,6 +13983,7 @@
           <a:lstStyle/>
           <a:p>
             <a:pPr algn="ctr"/>
+            <a:endParaRPr/>
           </a:p>
         </p:txBody>
       </p:sp>
@@ -13322,6 +14087,7 @@
                 </a:solidFill>
               </a:defRPr>
             </a:pPr>
+            <a:endParaRPr/>
           </a:p>
           <a:p>
             <a:pPr>
@@ -13421,6 +14187,7 @@
           <a:lstStyle/>
           <a:p>
             <a:pPr algn="ctr"/>
+            <a:endParaRPr/>
           </a:p>
         </p:txBody>
       </p:sp>
@@ -13524,6 +14291,7 @@
                 </a:solidFill>
               </a:defRPr>
             </a:pPr>
+            <a:endParaRPr/>
           </a:p>
           <a:p>
             <a:pPr>
@@ -13593,6 +14361,7 @@
                 </a:solidFill>
               </a:defRPr>
             </a:pPr>
+            <a:endParaRPr/>
           </a:p>
           <a:p>
             <a:pPr>
@@ -13641,7 +14410,7 @@
 </file>
 
 <file path=ppt/slides/slide36.xml><?xml version="1.0" encoding="utf-8"?>
-<p:sld xmlns:a="http://schemas.openxmlformats.org/drawingml/2006/main" xmlns:p="http://schemas.openxmlformats.org/presentationml/2006/main" xmlns:r="http://schemas.openxmlformats.org/officeDocument/2006/relationships">
+<p:sld xmlns:a="http://schemas.openxmlformats.org/drawingml/2006/main" xmlns:r="http://schemas.openxmlformats.org/officeDocument/2006/relationships" xmlns:p="http://schemas.openxmlformats.org/presentationml/2006/main">
   <p:cSld>
     <p:bg>
       <p:bgPr>
@@ -13657,7 +14426,14 @@
         <p:cNvGrpSpPr/>
         <p:nvPr/>
       </p:nvGrpSpPr>
-      <p:grpSpPr/>
+      <p:grpSpPr>
+        <a:xfrm>
+          <a:off x="0" y="0"/>
+          <a:ext cx="0" cy="0"/>
+          <a:chOff x="0" y="0"/>
+          <a:chExt cx="0" cy="0"/>
+        </a:xfrm>
+      </p:grpSpPr>
       <p:sp>
         <p:nvSpPr>
           <p:cNvPr id="2" name="Oval 1"/>
@@ -13694,7 +14470,7 @@
           </a:fontRef>
         </p:style>
         <p:txBody>
-          <a:bodyPr rtlCol="0" anchor="ctr" wrap="square"/>
+          <a:bodyPr wrap="square" rtlCol="0" anchor="ctr"/>
           <a:lstStyle/>
           <a:p>
             <a:pPr algn="ctr">
@@ -13754,7 +14530,7 @@
 </file>
 
 <file path=ppt/slides/slide37.xml><?xml version="1.0" encoding="utf-8"?>
-<p:sld xmlns:a="http://schemas.openxmlformats.org/drawingml/2006/main" xmlns:p="http://schemas.openxmlformats.org/presentationml/2006/main" xmlns:r="http://schemas.openxmlformats.org/officeDocument/2006/relationships">
+<p:sld xmlns:a="http://schemas.openxmlformats.org/drawingml/2006/main" xmlns:r="http://schemas.openxmlformats.org/officeDocument/2006/relationships" xmlns:p="http://schemas.openxmlformats.org/presentationml/2006/main">
   <p:cSld>
     <p:bg>
       <p:bgPr>
@@ -13770,7 +14546,14 @@
         <p:cNvGrpSpPr/>
         <p:nvPr/>
       </p:nvGrpSpPr>
-      <p:grpSpPr/>
+      <p:grpSpPr>
+        <a:xfrm>
+          <a:off x="0" y="0"/>
+          <a:ext cx="0" cy="0"/>
+          <a:chOff x="0" y="0"/>
+          <a:chExt cx="0" cy="0"/>
+        </a:xfrm>
+      </p:grpSpPr>
       <p:sp>
         <p:nvSpPr>
           <p:cNvPr id="2" name="TextBox 1"/>
@@ -13848,6 +14631,7 @@
           <a:lstStyle/>
           <a:p>
             <a:pPr algn="ctr"/>
+            <a:endParaRPr/>
           </a:p>
         </p:txBody>
       </p:sp>
@@ -13969,6 +14753,7 @@
                 </a:solidFill>
               </a:defRPr>
             </a:pPr>
+            <a:endParaRPr/>
           </a:p>
           <a:p>
             <a:pPr>
@@ -14020,6 +14805,7 @@
                 </a:solidFill>
               </a:defRPr>
             </a:pPr>
+            <a:endParaRPr/>
           </a:p>
           <a:p>
             <a:pPr>
@@ -14107,6 +14893,7 @@
                 </a:solidFill>
               </a:defRPr>
             </a:pPr>
+            <a:endParaRPr/>
           </a:p>
           <a:p>
             <a:pPr>
@@ -14188,6 +14975,7 @@
           <a:lstStyle/>
           <a:p>
             <a:pPr algn="ctr"/>
+            <a:endParaRPr/>
           </a:p>
         </p:txBody>
       </p:sp>
@@ -14309,6 +15097,7 @@
                 </a:solidFill>
               </a:defRPr>
             </a:pPr>
+            <a:endParaRPr/>
           </a:p>
           <a:p>
             <a:pPr>
@@ -14360,6 +15149,7 @@
                 </a:solidFill>
               </a:defRPr>
             </a:pPr>
+            <a:endParaRPr/>
           </a:p>
           <a:p>
             <a:pPr>
@@ -14411,6 +15201,7 @@
                 </a:solidFill>
               </a:defRPr>
             </a:pPr>
+            <a:endParaRPr/>
           </a:p>
           <a:p>
             <a:pPr>
@@ -14492,6 +15283,7 @@
           <a:lstStyle/>
           <a:p>
             <a:pPr algn="ctr"/>
+            <a:endParaRPr/>
           </a:p>
         </p:txBody>
       </p:sp>
@@ -14613,6 +15405,7 @@
                 </a:solidFill>
               </a:defRPr>
             </a:pPr>
+            <a:endParaRPr/>
           </a:p>
           <a:p>
             <a:pPr>
@@ -14664,6 +15457,7 @@
                 </a:solidFill>
               </a:defRPr>
             </a:pPr>
+            <a:endParaRPr/>
           </a:p>
           <a:p>
             <a:pPr>
@@ -14715,6 +15509,7 @@
                 </a:solidFill>
               </a:defRPr>
             </a:pPr>
+            <a:endParaRPr/>
           </a:p>
           <a:p>
             <a:pPr>
@@ -14799,7 +15594,7 @@
 </file>
 
 <file path=ppt/slides/slide38.xml><?xml version="1.0" encoding="utf-8"?>
-<p:sld xmlns:a="http://schemas.openxmlformats.org/drawingml/2006/main" xmlns:p="http://schemas.openxmlformats.org/presentationml/2006/main" xmlns:r="http://schemas.openxmlformats.org/officeDocument/2006/relationships">
+<p:sld xmlns:a="http://schemas.openxmlformats.org/drawingml/2006/main" xmlns:r="http://schemas.openxmlformats.org/officeDocument/2006/relationships" xmlns:p="http://schemas.openxmlformats.org/presentationml/2006/main">
   <p:cSld>
     <p:bg>
       <p:bgPr>
@@ -14815,7 +15610,14 @@
         <p:cNvGrpSpPr/>
         <p:nvPr/>
       </p:nvGrpSpPr>
-      <p:grpSpPr/>
+      <p:grpSpPr>
+        <a:xfrm>
+          <a:off x="0" y="0"/>
+          <a:ext cx="0" cy="0"/>
+          <a:chOff x="0" y="0"/>
+          <a:chExt cx="0" cy="0"/>
+        </a:xfrm>
+      </p:grpSpPr>
       <p:sp>
         <p:nvSpPr>
           <p:cNvPr id="2" name="TextBox 1"/>
@@ -14895,7 +15697,7 @@
 </file>
 
 <file path=ppt/slides/slide4.xml><?xml version="1.0" encoding="utf-8"?>
-<p:sld xmlns:a="http://schemas.openxmlformats.org/drawingml/2006/main" xmlns:p="http://schemas.openxmlformats.org/presentationml/2006/main" xmlns:r="http://schemas.openxmlformats.org/officeDocument/2006/relationships">
+<p:sld xmlns:a="http://schemas.openxmlformats.org/drawingml/2006/main" xmlns:r="http://schemas.openxmlformats.org/officeDocument/2006/relationships" xmlns:p="http://schemas.openxmlformats.org/presentationml/2006/main">
   <p:cSld>
     <p:bg>
       <p:bgPr>
@@ -14911,7 +15713,14 @@
         <p:cNvGrpSpPr/>
         <p:nvPr/>
       </p:nvGrpSpPr>
-      <p:grpSpPr/>
+      <p:grpSpPr>
+        <a:xfrm>
+          <a:off x="0" y="0"/>
+          <a:ext cx="0" cy="0"/>
+          <a:chOff x="0" y="0"/>
+          <a:chExt cx="0" cy="0"/>
+        </a:xfrm>
+      </p:grpSpPr>
       <p:sp>
         <p:nvSpPr>
           <p:cNvPr id="2" name="TextBox 1"/>
@@ -14989,6 +15798,7 @@
           <a:lstStyle/>
           <a:p>
             <a:pPr algn="ctr"/>
+            <a:endParaRPr/>
           </a:p>
         </p:txBody>
       </p:sp>
@@ -15110,6 +15920,7 @@
                 </a:solidFill>
               </a:defRPr>
             </a:pPr>
+            <a:endParaRPr/>
           </a:p>
           <a:p>
             <a:pPr>
@@ -15197,6 +16008,7 @@
                 </a:solidFill>
               </a:defRPr>
             </a:pPr>
+            <a:endParaRPr/>
           </a:p>
           <a:p>
             <a:pPr>
@@ -15296,6 +16108,7 @@
           <a:lstStyle/>
           <a:p>
             <a:pPr algn="ctr"/>
+            <a:endParaRPr/>
           </a:p>
         </p:txBody>
       </p:sp>
@@ -15417,6 +16230,7 @@
                 </a:solidFill>
               </a:defRPr>
             </a:pPr>
+            <a:endParaRPr/>
           </a:p>
           <a:p>
             <a:pPr>
@@ -15486,6 +16300,7 @@
                 </a:solidFill>
               </a:defRPr>
             </a:pPr>
+            <a:endParaRPr/>
           </a:p>
           <a:p>
             <a:pPr>
@@ -15549,6 +16364,7 @@
           <a:lstStyle/>
           <a:p>
             <a:pPr algn="ctr"/>
+            <a:endParaRPr/>
           </a:p>
         </p:txBody>
       </p:sp>
@@ -15670,6 +16486,7 @@
                 </a:solidFill>
               </a:defRPr>
             </a:pPr>
+            <a:endParaRPr/>
           </a:p>
           <a:p>
             <a:pPr>
@@ -15754,7 +16571,7 @@
 </file>
 
 <file path=ppt/slides/slide5.xml><?xml version="1.0" encoding="utf-8"?>
-<p:sld xmlns:a="http://schemas.openxmlformats.org/drawingml/2006/main" xmlns:p="http://schemas.openxmlformats.org/presentationml/2006/main" xmlns:r="http://schemas.openxmlformats.org/officeDocument/2006/relationships">
+<p:sld xmlns:a="http://schemas.openxmlformats.org/drawingml/2006/main" xmlns:r="http://schemas.openxmlformats.org/officeDocument/2006/relationships" xmlns:p="http://schemas.openxmlformats.org/presentationml/2006/main">
   <p:cSld>
     <p:bg>
       <p:bgPr>
@@ -15770,7 +16587,14 @@
         <p:cNvGrpSpPr/>
         <p:nvPr/>
       </p:nvGrpSpPr>
-      <p:grpSpPr/>
+      <p:grpSpPr>
+        <a:xfrm>
+          <a:off x="0" y="0"/>
+          <a:ext cx="0" cy="0"/>
+          <a:chOff x="0" y="0"/>
+          <a:chExt cx="0" cy="0"/>
+        </a:xfrm>
+      </p:grpSpPr>
       <p:sp>
         <p:nvSpPr>
           <p:cNvPr id="2" name="Oval 1"/>
@@ -15807,7 +16631,7 @@
           </a:fontRef>
         </p:style>
         <p:txBody>
-          <a:bodyPr rtlCol="0" anchor="ctr" wrap="square"/>
+          <a:bodyPr wrap="square" rtlCol="0" anchor="ctr"/>
           <a:lstStyle/>
           <a:p>
             <a:pPr algn="ctr">
@@ -15867,7 +16691,7 @@
 </file>
 
 <file path=ppt/slides/slide6.xml><?xml version="1.0" encoding="utf-8"?>
-<p:sld xmlns:a="http://schemas.openxmlformats.org/drawingml/2006/main" xmlns:p="http://schemas.openxmlformats.org/presentationml/2006/main" xmlns:r="http://schemas.openxmlformats.org/officeDocument/2006/relationships">
+<p:sld xmlns:a="http://schemas.openxmlformats.org/drawingml/2006/main" xmlns:r="http://schemas.openxmlformats.org/officeDocument/2006/relationships" xmlns:p="http://schemas.openxmlformats.org/presentationml/2006/main">
   <p:cSld>
     <p:bg>
       <p:bgPr>
@@ -15883,7 +16707,14 @@
         <p:cNvGrpSpPr/>
         <p:nvPr/>
       </p:nvGrpSpPr>
-      <p:grpSpPr/>
+      <p:grpSpPr>
+        <a:xfrm>
+          <a:off x="0" y="0"/>
+          <a:ext cx="0" cy="0"/>
+          <a:chOff x="0" y="0"/>
+          <a:chExt cx="0" cy="0"/>
+        </a:xfrm>
+      </p:grpSpPr>
       <p:sp>
         <p:nvSpPr>
           <p:cNvPr id="2" name="TextBox 1"/>
@@ -15961,6 +16792,7 @@
           <a:lstStyle/>
           <a:p>
             <a:pPr algn="ctr"/>
+            <a:endParaRPr/>
           </a:p>
         </p:txBody>
       </p:sp>
@@ -16064,6 +16896,7 @@
                 </a:solidFill>
               </a:defRPr>
             </a:pPr>
+            <a:endParaRPr/>
           </a:p>
           <a:p>
             <a:pPr>
@@ -16115,6 +16948,7 @@
                 </a:solidFill>
               </a:defRPr>
             </a:pPr>
+            <a:endParaRPr/>
           </a:p>
           <a:p>
             <a:pPr>
@@ -16232,6 +17066,7 @@
           <a:lstStyle/>
           <a:p>
             <a:pPr algn="ctr"/>
+            <a:endParaRPr/>
           </a:p>
         </p:txBody>
       </p:sp>
@@ -16335,6 +17170,7 @@
                 </a:solidFill>
               </a:defRPr>
             </a:pPr>
+            <a:endParaRPr/>
           </a:p>
           <a:p>
             <a:pPr>
@@ -16386,6 +17222,7 @@
                 </a:solidFill>
               </a:defRPr>
             </a:pPr>
+            <a:endParaRPr/>
           </a:p>
           <a:p>
             <a:pPr>
@@ -16437,6 +17274,7 @@
                 </a:solidFill>
               </a:defRPr>
             </a:pPr>
+            <a:endParaRPr/>
           </a:p>
           <a:p>
             <a:pPr>
@@ -16536,6 +17374,7 @@
           <a:lstStyle/>
           <a:p>
             <a:pPr algn="ctr"/>
+            <a:endParaRPr/>
           </a:p>
         </p:txBody>
       </p:sp>
@@ -16657,6 +17496,7 @@
                 </a:solidFill>
               </a:defRPr>
             </a:pPr>
+            <a:endParaRPr/>
           </a:p>
           <a:p>
             <a:pPr>
@@ -16708,6 +17548,7 @@
                 </a:solidFill>
               </a:defRPr>
             </a:pPr>
+            <a:endParaRPr/>
           </a:p>
           <a:p>
             <a:pPr>
@@ -16792,7 +17633,7 @@
 </file>
 
 <file path=ppt/slides/slide7.xml><?xml version="1.0" encoding="utf-8"?>
-<p:sld xmlns:a="http://schemas.openxmlformats.org/drawingml/2006/main" xmlns:p="http://schemas.openxmlformats.org/presentationml/2006/main" xmlns:r="http://schemas.openxmlformats.org/officeDocument/2006/relationships">
+<p:sld xmlns:a="http://schemas.openxmlformats.org/drawingml/2006/main" xmlns:r="http://schemas.openxmlformats.org/officeDocument/2006/relationships" xmlns:p="http://schemas.openxmlformats.org/presentationml/2006/main">
   <p:cSld>
     <p:bg>
       <p:bgPr>
@@ -16808,7 +17649,14 @@
         <p:cNvGrpSpPr/>
         <p:nvPr/>
       </p:nvGrpSpPr>
-      <p:grpSpPr/>
+      <p:grpSpPr>
+        <a:xfrm>
+          <a:off x="0" y="0"/>
+          <a:ext cx="0" cy="0"/>
+          <a:chOff x="0" y="0"/>
+          <a:chExt cx="0" cy="0"/>
+        </a:xfrm>
+      </p:grpSpPr>
       <p:sp>
         <p:nvSpPr>
           <p:cNvPr id="2" name="TextBox 1"/>
@@ -16863,11 +17711,41 @@
                 <a:tableStyleId>{5C22544A-7EE6-4342-B048-85BDC9FD1C3A}</a:tableStyleId>
               </a:tblPr>
               <a:tblGrid>
-                <a:gridCol w="2194560"/>
-                <a:gridCol w="2194560"/>
-                <a:gridCol w="2194560"/>
-                <a:gridCol w="2194560"/>
-                <a:gridCol w="2194560"/>
+                <a:gridCol w="2194560">
+                  <a:extLst>
+                    <a:ext uri="{9D8B030D-6E8A-4147-A177-3AD203B41FA5}">
+                      <a16:colId xmlns:a16="http://schemas.microsoft.com/office/drawing/2014/main" val="20000"/>
+                    </a:ext>
+                  </a:extLst>
+                </a:gridCol>
+                <a:gridCol w="2194560">
+                  <a:extLst>
+                    <a:ext uri="{9D8B030D-6E8A-4147-A177-3AD203B41FA5}">
+                      <a16:colId xmlns:a16="http://schemas.microsoft.com/office/drawing/2014/main" val="20001"/>
+                    </a:ext>
+                  </a:extLst>
+                </a:gridCol>
+                <a:gridCol w="2194560">
+                  <a:extLst>
+                    <a:ext uri="{9D8B030D-6E8A-4147-A177-3AD203B41FA5}">
+                      <a16:colId xmlns:a16="http://schemas.microsoft.com/office/drawing/2014/main" val="20002"/>
+                    </a:ext>
+                  </a:extLst>
+                </a:gridCol>
+                <a:gridCol w="2194560">
+                  <a:extLst>
+                    <a:ext uri="{9D8B030D-6E8A-4147-A177-3AD203B41FA5}">
+                      <a16:colId xmlns:a16="http://schemas.microsoft.com/office/drawing/2014/main" val="20003"/>
+                    </a:ext>
+                  </a:extLst>
+                </a:gridCol>
+                <a:gridCol w="2194560">
+                  <a:extLst>
+                    <a:ext uri="{9D8B030D-6E8A-4147-A177-3AD203B41FA5}">
+                      <a16:colId xmlns:a16="http://schemas.microsoft.com/office/drawing/2014/main" val="20004"/>
+                    </a:ext>
+                  </a:extLst>
+                </a:gridCol>
               </a:tblGrid>
               <a:tr h="571500">
                 <a:tc>
@@ -16985,6 +17863,11 @@
                     </a:solidFill>
                   </a:tcPr>
                 </a:tc>
+                <a:extLst>
+                  <a:ext uri="{0D108BD9-81ED-4DB2-BD59-A6C34878D82A}">
+                    <a16:rowId xmlns:a16="http://schemas.microsoft.com/office/drawing/2014/main" val="10000"/>
+                  </a:ext>
+                </a:extLst>
               </a:tr>
               <a:tr h="571500">
                 <a:tc>
@@ -17102,6 +17985,11 @@
                     </a:solidFill>
                   </a:tcPr>
                 </a:tc>
+                <a:extLst>
+                  <a:ext uri="{0D108BD9-81ED-4DB2-BD59-A6C34878D82A}">
+                    <a16:rowId xmlns:a16="http://schemas.microsoft.com/office/drawing/2014/main" val="10001"/>
+                  </a:ext>
+                </a:extLst>
               </a:tr>
               <a:tr h="571500">
                 <a:tc>
@@ -17219,6 +18107,11 @@
                     </a:solidFill>
                   </a:tcPr>
                 </a:tc>
+                <a:extLst>
+                  <a:ext uri="{0D108BD9-81ED-4DB2-BD59-A6C34878D82A}">
+                    <a16:rowId xmlns:a16="http://schemas.microsoft.com/office/drawing/2014/main" val="10002"/>
+                  </a:ext>
+                </a:extLst>
               </a:tr>
               <a:tr h="571500">
                 <a:tc>
@@ -17336,6 +18229,11 @@
                     </a:solidFill>
                   </a:tcPr>
                 </a:tc>
+                <a:extLst>
+                  <a:ext uri="{0D108BD9-81ED-4DB2-BD59-A6C34878D82A}">
+                    <a16:rowId xmlns:a16="http://schemas.microsoft.com/office/drawing/2014/main" val="10003"/>
+                  </a:ext>
+                </a:extLst>
               </a:tr>
             </a:tbl>
           </a:graphicData>
@@ -17350,7 +18248,7 @@
 </file>
 
 <file path=ppt/slides/slide8.xml><?xml version="1.0" encoding="utf-8"?>
-<p:sld xmlns:a="http://schemas.openxmlformats.org/drawingml/2006/main" xmlns:p="http://schemas.openxmlformats.org/presentationml/2006/main" xmlns:r="http://schemas.openxmlformats.org/officeDocument/2006/relationships">
+<p:sld xmlns:a="http://schemas.openxmlformats.org/drawingml/2006/main" xmlns:r="http://schemas.openxmlformats.org/officeDocument/2006/relationships" xmlns:p="http://schemas.openxmlformats.org/presentationml/2006/main">
   <p:cSld>
     <p:bg>
       <p:bgPr>
@@ -17366,7 +18264,14 @@
         <p:cNvGrpSpPr/>
         <p:nvPr/>
       </p:nvGrpSpPr>
-      <p:grpSpPr/>
+      <p:grpSpPr>
+        <a:xfrm>
+          <a:off x="0" y="0"/>
+          <a:ext cx="0" cy="0"/>
+          <a:chOff x="0" y="0"/>
+          <a:chExt cx="0" cy="0"/>
+        </a:xfrm>
+      </p:grpSpPr>
       <p:sp>
         <p:nvSpPr>
           <p:cNvPr id="2" name="Oval 1"/>
@@ -17403,7 +18308,7 @@
           </a:fontRef>
         </p:style>
         <p:txBody>
-          <a:bodyPr rtlCol="0" anchor="ctr" wrap="square"/>
+          <a:bodyPr wrap="square" rtlCol="0" anchor="ctr"/>
           <a:lstStyle/>
           <a:p>
             <a:pPr algn="ctr">
@@ -17463,7 +18368,7 @@
 </file>
 
 <file path=ppt/slides/slide9.xml><?xml version="1.0" encoding="utf-8"?>
-<p:sld xmlns:a="http://schemas.openxmlformats.org/drawingml/2006/main" xmlns:p="http://schemas.openxmlformats.org/presentationml/2006/main" xmlns:r="http://schemas.openxmlformats.org/officeDocument/2006/relationships">
+<p:sld xmlns:a="http://schemas.openxmlformats.org/drawingml/2006/main" xmlns:r="http://schemas.openxmlformats.org/officeDocument/2006/relationships" xmlns:p="http://schemas.openxmlformats.org/presentationml/2006/main">
   <p:cSld>
     <p:bg>
       <p:bgPr>
@@ -17479,7 +18384,14 @@
         <p:cNvGrpSpPr/>
         <p:nvPr/>
       </p:nvGrpSpPr>
-      <p:grpSpPr/>
+      <p:grpSpPr>
+        <a:xfrm>
+          <a:off x="0" y="0"/>
+          <a:ext cx="0" cy="0"/>
+          <a:chOff x="0" y="0"/>
+          <a:chExt cx="0" cy="0"/>
+        </a:xfrm>
+      </p:grpSpPr>
       <p:sp>
         <p:nvSpPr>
           <p:cNvPr id="2" name="TextBox 1"/>
@@ -17557,6 +18469,7 @@
           <a:lstStyle/>
           <a:p>
             <a:pPr algn="ctr"/>
+            <a:endParaRPr/>
           </a:p>
         </p:txBody>
       </p:sp>
@@ -17714,6 +18627,7 @@
                 </a:solidFill>
               </a:defRPr>
             </a:pPr>
+            <a:endParaRPr/>
           </a:p>
           <a:p>
             <a:pPr>
@@ -17765,6 +18679,7 @@
                 </a:solidFill>
               </a:defRPr>
             </a:pPr>
+            <a:endParaRPr/>
           </a:p>
           <a:p>
             <a:pPr>
@@ -17864,6 +18779,7 @@
           <a:lstStyle/>
           <a:p>
             <a:pPr algn="ctr"/>
+            <a:endParaRPr/>
           </a:p>
         </p:txBody>
       </p:sp>
@@ -18057,6 +18973,7 @@
                 </a:solidFill>
               </a:defRPr>
             </a:pPr>
+            <a:endParaRPr/>
           </a:p>
           <a:p>
             <a:pPr>
@@ -18138,6 +19055,7 @@
           <a:lstStyle/>
           <a:p>
             <a:pPr algn="ctr"/>
+            <a:endParaRPr/>
           </a:p>
         </p:txBody>
       </p:sp>
@@ -18331,6 +19249,7 @@
                 </a:solidFill>
               </a:defRPr>
             </a:pPr>
+            <a:endParaRPr/>
           </a:p>
           <a:p>
             <a:pPr>

</xml_diff>